<commit_message>
Refactor battery model training and hyperparameter tuning
- Removed the README.md file from results directory.
- Updated the plot_comparison_distances function to remove SOC RMSE and power RMSE plots, simplifying the comparison visualization.
- Added a new hyperparameter tuning script using Optuna for the Battery SAC model, encapsulating the tuning logic and logging.
- Updated model_comparison.txt with new results reflecting changes in model performance metrics.
- Refactored train.py to utilize the new hyperparameter tuning function, streamlining the training process.
</commit_message>
<xml_diff>
--- a/Presentations/Thesis Update(first case)- 04-03-2026.pptx
+++ b/Presentations/Thesis Update(first case)- 04-03-2026.pptx
@@ -5,10 +5,10 @@
     <p:sldMasterId id="2147483648" r:id="rId1"/>
   </p:sldMasterIdLst>
   <p:notesMasterIdLst>
-    <p:notesMasterId r:id="rId22"/>
+    <p:notesMasterId r:id="rId23"/>
   </p:notesMasterIdLst>
   <p:handoutMasterIdLst>
-    <p:handoutMasterId r:id="rId23"/>
+    <p:handoutMasterId r:id="rId24"/>
   </p:handoutMasterIdLst>
   <p:sldIdLst>
     <p:sldId id="271" r:id="rId2"/>
@@ -16,28 +16,29 @@
     <p:sldId id="266" r:id="rId4"/>
     <p:sldId id="268" r:id="rId5"/>
     <p:sldId id="269" r:id="rId6"/>
-    <p:sldId id="270" r:id="rId7"/>
-    <p:sldId id="289" r:id="rId8"/>
-    <p:sldId id="264" r:id="rId9"/>
-    <p:sldId id="265" r:id="rId10"/>
-    <p:sldId id="274" r:id="rId11"/>
-    <p:sldId id="276" r:id="rId12"/>
-    <p:sldId id="277" r:id="rId13"/>
-    <p:sldId id="288" r:id="rId14"/>
-    <p:sldId id="281" r:id="rId15"/>
-    <p:sldId id="280" r:id="rId16"/>
-    <p:sldId id="290" r:id="rId17"/>
-    <p:sldId id="275" r:id="rId18"/>
-    <p:sldId id="279" r:id="rId19"/>
-    <p:sldId id="278" r:id="rId20"/>
-    <p:sldId id="267" r:id="rId21"/>
+    <p:sldId id="292" r:id="rId7"/>
+    <p:sldId id="270" r:id="rId8"/>
+    <p:sldId id="289" r:id="rId9"/>
+    <p:sldId id="264" r:id="rId10"/>
+    <p:sldId id="265" r:id="rId11"/>
+    <p:sldId id="274" r:id="rId12"/>
+    <p:sldId id="276" r:id="rId13"/>
+    <p:sldId id="293" r:id="rId14"/>
+    <p:sldId id="291" r:id="rId15"/>
+    <p:sldId id="275" r:id="rId16"/>
+    <p:sldId id="281" r:id="rId17"/>
+    <p:sldId id="280" r:id="rId18"/>
+    <p:sldId id="290" r:id="rId19"/>
+    <p:sldId id="279" r:id="rId20"/>
+    <p:sldId id="278" r:id="rId21"/>
+    <p:sldId id="267" r:id="rId22"/>
   </p:sldIdLst>
   <p:sldSz cx="14630400" cy="8229600"/>
   <p:notesSz cx="8229600" cy="14630400"/>
   <p:embeddedFontLst>
     <p:embeddedFont>
       <p:font typeface="Cambria Math" panose="02040503050406030204" pitchFamily="18" charset="0"/>
-      <p:regular r:id="rId24"/>
+      <p:regular r:id="rId25"/>
     </p:embeddedFont>
   </p:embeddedFontLst>
   <p:defaultTextStyle>
@@ -1687,6 +1688,353 @@
           <a:chExt cx="0" cy="0"/>
         </a:xfrm>
       </p:grpSpPr>
+      <p:sp>
+        <p:nvSpPr>
+          <p:cNvPr id="5" name="Shape 4">
+            <a:extLst>
+              <a:ext uri="{FF2B5EF4-FFF2-40B4-BE49-F238E27FC236}">
+                <a16:creationId xmlns:a16="http://schemas.microsoft.com/office/drawing/2014/main" id="{01E4604A-A2F2-75F3-0A53-CA6CEEF5588D}"/>
+              </a:ext>
+            </a:extLst>
+          </p:cNvPr>
+          <p:cNvSpPr/>
+          <p:nvPr/>
+        </p:nvSpPr>
+        <p:spPr>
+          <a:xfrm>
+            <a:off x="1252800" y="2697493"/>
+            <a:ext cx="6608494" cy="3522054"/>
+          </a:xfrm>
+          <a:prstGeom prst="roundRect">
+            <a:avLst>
+              <a:gd name="adj" fmla="val 4335"/>
+            </a:avLst>
+          </a:prstGeom>
+          <a:solidFill>
+            <a:srgbClr val="D2DDF9"/>
+          </a:solidFill>
+          <a:ln/>
+        </p:spPr>
+        <p:txBody>
+          <a:bodyPr/>
+          <a:lstStyle/>
+          <a:p>
+            <a:endParaRPr lang="de-DE">
+              <a:latin typeface="Arial" panose="020B0604020202020204" pitchFamily="34" charset="0"/>
+              <a:cs typeface="Arial" panose="020B0604020202020204" pitchFamily="34" charset="0"/>
+            </a:endParaRPr>
+          </a:p>
+        </p:txBody>
+      </p:sp>
+      <p:sp>
+        <p:nvSpPr>
+          <p:cNvPr id="2" name="Text 1">
+            <a:extLst>
+              <a:ext uri="{FF2B5EF4-FFF2-40B4-BE49-F238E27FC236}">
+                <a16:creationId xmlns:a16="http://schemas.microsoft.com/office/drawing/2014/main" id="{C62DF92F-1163-B150-A05D-661A035DACD9}"/>
+              </a:ext>
+            </a:extLst>
+          </p:cNvPr>
+          <p:cNvSpPr/>
+          <p:nvPr/>
+        </p:nvSpPr>
+        <p:spPr>
+          <a:xfrm>
+            <a:off x="1483201" y="2600711"/>
+            <a:ext cx="6127200" cy="3715618"/>
+          </a:xfrm>
+          <a:prstGeom prst="rect">
+            <a:avLst/>
+          </a:prstGeom>
+          <a:noFill/>
+          <a:ln/>
+        </p:spPr>
+        <p:txBody>
+          <a:bodyPr wrap="none" lIns="0" tIns="0" rIns="0" bIns="0" rtlCol="0" anchor="t"/>
+          <a:lstStyle/>
+          <a:p>
+            <a:pPr marL="0" indent="0" algn="l">
+              <a:lnSpc>
+                <a:spcPts val="2850"/>
+              </a:lnSpc>
+              <a:buNone/>
+            </a:pPr>
+            <a:endParaRPr lang="en-US" sz="1750" dirty="0">
+              <a:latin typeface="Arial" panose="020B0604020202020204" pitchFamily="34" charset="0"/>
+              <a:ea typeface="Heebo" pitchFamily="34" charset="-122"/>
+              <a:cs typeface="Arial" panose="020B0604020202020204" pitchFamily="34" charset="0"/>
+            </a:endParaRPr>
+          </a:p>
+          <a:p>
+            <a:pPr marL="0" indent="0" algn="l">
+              <a:lnSpc>
+                <a:spcPts val="2850"/>
+              </a:lnSpc>
+              <a:buNone/>
+            </a:pPr>
+            <a:r>
+              <a:rPr lang="en-US" sz="2400" b="1" dirty="0">
+                <a:latin typeface="Arial" panose="020B0604020202020204" pitchFamily="34" charset="0"/>
+                <a:ea typeface="Heebo" pitchFamily="34" charset="-122"/>
+                <a:cs typeface="Arial" panose="020B0604020202020204" pitchFamily="34" charset="0"/>
+              </a:rPr>
+              <a:t>Strengths:</a:t>
+            </a:r>
+          </a:p>
+          <a:p>
+            <a:pPr marL="285750" indent="-285750" algn="l">
+              <a:lnSpc>
+                <a:spcPts val="2850"/>
+              </a:lnSpc>
+              <a:buFont typeface="Arial" panose="020B0604020202020204" pitchFamily="34" charset="0"/>
+              <a:buChar char="•"/>
+            </a:pPr>
+            <a:r>
+              <a:rPr lang="en-US" dirty="0">
+                <a:latin typeface="Arial" panose="020B0604020202020204" pitchFamily="34" charset="0"/>
+                <a:ea typeface="Heebo" pitchFamily="34" charset="-122"/>
+                <a:cs typeface="Arial" panose="020B0604020202020204" pitchFamily="34" charset="0"/>
+              </a:rPr>
+              <a:t>31/32 runs (96%) achieved near-optimal performance</a:t>
+            </a:r>
+          </a:p>
+          <a:p>
+            <a:pPr marL="285750" indent="-285750" algn="l">
+              <a:lnSpc>
+                <a:spcPts val="2850"/>
+              </a:lnSpc>
+              <a:buFont typeface="Arial" panose="020B0604020202020204" pitchFamily="34" charset="0"/>
+              <a:buChar char="•"/>
+            </a:pPr>
+            <a:r>
+              <a:rPr lang="en-US" dirty="0">
+                <a:latin typeface="Arial" panose="020B0604020202020204" pitchFamily="34" charset="0"/>
+                <a:ea typeface="Heebo" pitchFamily="34" charset="-122"/>
+                <a:cs typeface="Arial" panose="020B0604020202020204" pitchFamily="34" charset="0"/>
+              </a:rPr>
+              <a:t>Stable and consistent learning behavior</a:t>
+            </a:r>
+          </a:p>
+          <a:p>
+            <a:pPr marL="285750" indent="-285750" algn="l">
+              <a:lnSpc>
+                <a:spcPts val="2850"/>
+              </a:lnSpc>
+              <a:buFont typeface="Arial" panose="020B0604020202020204" pitchFamily="34" charset="0"/>
+              <a:buChar char="•"/>
+            </a:pPr>
+            <a:r>
+              <a:rPr lang="en-US" dirty="0">
+                <a:latin typeface="Arial" panose="020B0604020202020204" pitchFamily="34" charset="0"/>
+                <a:ea typeface="Heebo" pitchFamily="34" charset="-122"/>
+                <a:cs typeface="Arial" panose="020B0604020202020204" pitchFamily="34" charset="0"/>
+              </a:rPr>
+              <a:t>Model is robust to random initialization</a:t>
+            </a:r>
+          </a:p>
+          <a:p>
+            <a:pPr marL="0" indent="0" algn="l">
+              <a:lnSpc>
+                <a:spcPts val="2850"/>
+              </a:lnSpc>
+              <a:buNone/>
+            </a:pPr>
+            <a:endParaRPr lang="en-US" sz="1750" dirty="0">
+              <a:latin typeface="Arial" panose="020B0604020202020204" pitchFamily="34" charset="0"/>
+              <a:ea typeface="Heebo" pitchFamily="34" charset="-122"/>
+              <a:cs typeface="Arial" panose="020B0604020202020204" pitchFamily="34" charset="0"/>
+            </a:endParaRPr>
+          </a:p>
+          <a:p>
+            <a:pPr marL="0" indent="0" algn="l">
+              <a:lnSpc>
+                <a:spcPts val="2850"/>
+              </a:lnSpc>
+              <a:buNone/>
+            </a:pPr>
+            <a:r>
+              <a:rPr lang="en-US" sz="2400" b="1" dirty="0">
+                <a:latin typeface="Arial" panose="020B0604020202020204" pitchFamily="34" charset="0"/>
+                <a:ea typeface="Heebo" pitchFamily="34" charset="-122"/>
+                <a:cs typeface="Arial" panose="020B0604020202020204" pitchFamily="34" charset="0"/>
+              </a:rPr>
+              <a:t>Weaknesses:</a:t>
+            </a:r>
+          </a:p>
+          <a:p>
+            <a:pPr marL="285750" indent="-285750" algn="l">
+              <a:lnSpc>
+                <a:spcPts val="2850"/>
+              </a:lnSpc>
+              <a:buFont typeface="Arial" panose="020B0604020202020204" pitchFamily="34" charset="0"/>
+              <a:buChar char="•"/>
+            </a:pPr>
+            <a:r>
+              <a:rPr lang="en-US" dirty="0">
+                <a:latin typeface="Arial" panose="020B0604020202020204" pitchFamily="34" charset="0"/>
+                <a:ea typeface="Heebo" pitchFamily="34" charset="-122"/>
+                <a:cs typeface="Arial" panose="020B0604020202020204" pitchFamily="34" charset="0"/>
+              </a:rPr>
+              <a:t>4% chance of suboptimal convergence (1 outliers)</a:t>
+            </a:r>
+          </a:p>
+          <a:p>
+            <a:pPr marL="285750" indent="-285750" algn="l">
+              <a:lnSpc>
+                <a:spcPts val="2850"/>
+              </a:lnSpc>
+              <a:buFont typeface="Arial" panose="020B0604020202020204" pitchFamily="34" charset="0"/>
+              <a:buChar char="•"/>
+            </a:pPr>
+            <a:r>
+              <a:rPr lang="en-US" dirty="0">
+                <a:latin typeface="Arial" panose="020B0604020202020204" pitchFamily="34" charset="0"/>
+                <a:ea typeface="Heebo" pitchFamily="34" charset="-122"/>
+                <a:cs typeface="Arial" panose="020B0604020202020204" pitchFamily="34" charset="0"/>
+              </a:rPr>
+              <a:t>Optimality of the learned policy cannot be guaranteed</a:t>
+            </a:r>
+          </a:p>
+        </p:txBody>
+      </p:sp>
+      <p:sp>
+        <p:nvSpPr>
+          <p:cNvPr id="3" name="TextBox 2">
+            <a:extLst>
+              <a:ext uri="{FF2B5EF4-FFF2-40B4-BE49-F238E27FC236}">
+                <a16:creationId xmlns:a16="http://schemas.microsoft.com/office/drawing/2014/main" id="{F520DBB0-400F-6963-5E18-A67AA7D3E61D}"/>
+              </a:ext>
+            </a:extLst>
+          </p:cNvPr>
+          <p:cNvSpPr txBox="1"/>
+          <p:nvPr/>
+        </p:nvSpPr>
+        <p:spPr>
+          <a:xfrm>
+            <a:off x="1252800" y="634032"/>
+            <a:ext cx="8510400" cy="461665"/>
+          </a:xfrm>
+          <a:prstGeom prst="rect">
+            <a:avLst/>
+          </a:prstGeom>
+          <a:noFill/>
+        </p:spPr>
+        <p:txBody>
+          <a:bodyPr wrap="square" rtlCol="0">
+            <a:spAutoFit/>
+          </a:bodyPr>
+          <a:lstStyle/>
+          <a:p>
+            <a:r>
+              <a:rPr lang="en-US" sz="2400" b="1" i="0" dirty="0">
+                <a:effectLst/>
+                <a:latin typeface="Arial" panose="020B0604020202020204" pitchFamily="34" charset="0"/>
+                <a:cs typeface="Arial" panose="020B0604020202020204" pitchFamily="34" charset="0"/>
+              </a:rPr>
+              <a:t>Analysis of RL Battery Optimization Box Plot (32 Runs)</a:t>
+            </a:r>
+            <a:endParaRPr lang="de-DE" sz="2400" dirty="0">
+              <a:latin typeface="Arial" panose="020B0604020202020204" pitchFamily="34" charset="0"/>
+              <a:cs typeface="Arial" panose="020B0604020202020204" pitchFamily="34" charset="0"/>
+            </a:endParaRPr>
+          </a:p>
+        </p:txBody>
+      </p:sp>
+      <p:sp>
+        <p:nvSpPr>
+          <p:cNvPr id="4" name="TextBox 3">
+            <a:extLst>
+              <a:ext uri="{FF2B5EF4-FFF2-40B4-BE49-F238E27FC236}">
+                <a16:creationId xmlns:a16="http://schemas.microsoft.com/office/drawing/2014/main" id="{DC33ECBD-FB5C-26D7-0EBE-F0CD0278B8AA}"/>
+              </a:ext>
+            </a:extLst>
+          </p:cNvPr>
+          <p:cNvSpPr txBox="1"/>
+          <p:nvPr/>
+        </p:nvSpPr>
+        <p:spPr>
+          <a:xfrm>
+            <a:off x="1252800" y="1304257"/>
+            <a:ext cx="10021132" cy="923330"/>
+          </a:xfrm>
+          <a:prstGeom prst="rect">
+            <a:avLst/>
+          </a:prstGeom>
+          <a:noFill/>
+        </p:spPr>
+        <p:txBody>
+          <a:bodyPr wrap="square" rtlCol="0">
+            <a:spAutoFit/>
+          </a:bodyPr>
+          <a:lstStyle/>
+          <a:p>
+            <a:r>
+              <a:rPr lang="en-US" dirty="0"/>
+              <a:t>The linear learning rate schedule performs best because it achieves the lowest median cost and maintains a tight distribution across runs, indicating stable and reliable convergence. The linear decay allows large updates during early exploration and smaller updates for fine policy refinement later in training.</a:t>
+            </a:r>
+            <a:endParaRPr lang="de-DE" dirty="0"/>
+          </a:p>
+        </p:txBody>
+      </p:sp>
+      <p:sp>
+        <p:nvSpPr>
+          <p:cNvPr id="7" name="Slide Number Placeholder 6">
+            <a:extLst>
+              <a:ext uri="{FF2B5EF4-FFF2-40B4-BE49-F238E27FC236}">
+                <a16:creationId xmlns:a16="http://schemas.microsoft.com/office/drawing/2014/main" id="{CB67F05D-BF83-0E4E-252C-F73DCCA6881F}"/>
+              </a:ext>
+            </a:extLst>
+          </p:cNvPr>
+          <p:cNvSpPr>
+            <a:spLocks noGrp="1"/>
+          </p:cNvSpPr>
+          <p:nvPr>
+            <p:ph type="sldNum" sz="quarter" idx="10"/>
+          </p:nvPr>
+        </p:nvSpPr>
+        <p:spPr/>
+        <p:txBody>
+          <a:bodyPr/>
+          <a:lstStyle/>
+          <a:p>
+            <a:fld id="{A02D9A9C-251E-4686-914B-47E3F39F30D8}" type="slidenum">
+              <a:rPr lang="de-DE" smtClean="0"/>
+              <a:t>10</a:t>
+            </a:fld>
+            <a:endParaRPr lang="de-DE"/>
+          </a:p>
+        </p:txBody>
+      </p:sp>
+    </p:spTree>
+    <p:extLst>
+      <p:ext uri="{BB962C8B-B14F-4D97-AF65-F5344CB8AC3E}">
+        <p14:creationId xmlns:p14="http://schemas.microsoft.com/office/powerpoint/2010/main" val="3161864785"/>
+      </p:ext>
+    </p:extLst>
+  </p:cSld>
+  <p:clrMapOvr>
+    <a:masterClrMapping/>
+  </p:clrMapOvr>
+</p:sld>
+</file>
+
+<file path=ppt/slides/slide11.xml><?xml version="1.0" encoding="utf-8"?>
+<p:sld xmlns:a="http://schemas.openxmlformats.org/drawingml/2006/main" xmlns:r="http://schemas.openxmlformats.org/officeDocument/2006/relationships" xmlns:p="http://schemas.openxmlformats.org/presentationml/2006/main">
+  <p:cSld>
+    <p:spTree>
+      <p:nvGrpSpPr>
+        <p:cNvPr id="1" name=""/>
+        <p:cNvGrpSpPr/>
+        <p:nvPr/>
+      </p:nvGrpSpPr>
+      <p:grpSpPr>
+        <a:xfrm>
+          <a:off x="0" y="0"/>
+          <a:ext cx="0" cy="0"/>
+          <a:chOff x="0" y="0"/>
+          <a:chExt cx="0" cy="0"/>
+        </a:xfrm>
+      </p:grpSpPr>
       <p:pic>
         <p:nvPicPr>
           <p:cNvPr id="3" name="Picture 2">
@@ -1818,7 +2166,7 @@
           <a:p>
             <a:fld id="{A02D9A9C-251E-4686-914B-47E3F39F30D8}" type="slidenum">
               <a:rPr lang="de-DE" smtClean="0"/>
-              <a:t>10</a:t>
+              <a:t>11</a:t>
             </a:fld>
             <a:endParaRPr lang="de-DE"/>
           </a:p>
@@ -1837,7 +2185,7 @@
 </p:sld>
 </file>
 
-<file path=ppt/slides/slide11.xml><?xml version="1.0" encoding="utf-8"?>
+<file path=ppt/slides/slide12.xml><?xml version="1.0" encoding="utf-8"?>
 <p:sld xmlns:a="http://schemas.openxmlformats.org/drawingml/2006/main" xmlns:r="http://schemas.openxmlformats.org/officeDocument/2006/relationships" xmlns:p="http://schemas.openxmlformats.org/presentationml/2006/main">
   <p:cSld>
     <p:spTree>
@@ -1915,7 +2263,7 @@
           <a:p>
             <a:fld id="{A02D9A9C-251E-4686-914B-47E3F39F30D8}" type="slidenum">
               <a:rPr lang="de-DE" smtClean="0"/>
-              <a:t>11</a:t>
+              <a:t>12</a:t>
             </a:fld>
             <a:endParaRPr lang="de-DE"/>
           </a:p>
@@ -2222,153 +2570,6 @@
 </p:sld>
 </file>
 
-<file path=ppt/slides/slide12.xml><?xml version="1.0" encoding="utf-8"?>
-<p:sld xmlns:a="http://schemas.openxmlformats.org/drawingml/2006/main" xmlns:r="http://schemas.openxmlformats.org/officeDocument/2006/relationships" xmlns:p="http://schemas.openxmlformats.org/presentationml/2006/main">
-  <p:cSld>
-    <p:spTree>
-      <p:nvGrpSpPr>
-        <p:cNvPr id="1" name=""/>
-        <p:cNvGrpSpPr/>
-        <p:nvPr/>
-      </p:nvGrpSpPr>
-      <p:grpSpPr>
-        <a:xfrm>
-          <a:off x="0" y="0"/>
-          <a:ext cx="0" cy="0"/>
-          <a:chOff x="0" y="0"/>
-          <a:chExt cx="0" cy="0"/>
-        </a:xfrm>
-      </p:grpSpPr>
-      <p:sp>
-        <p:nvSpPr>
-          <p:cNvPr id="2" name="Slide Number Placeholder 1">
-            <a:extLst>
-              <a:ext uri="{FF2B5EF4-FFF2-40B4-BE49-F238E27FC236}">
-                <a16:creationId xmlns:a16="http://schemas.microsoft.com/office/drawing/2014/main" id="{FD487D02-6950-31EE-9075-CE462E154503}"/>
-              </a:ext>
-            </a:extLst>
-          </p:cNvPr>
-          <p:cNvSpPr>
-            <a:spLocks noGrp="1"/>
-          </p:cNvSpPr>
-          <p:nvPr>
-            <p:ph type="sldNum" sz="quarter" idx="10"/>
-          </p:nvPr>
-        </p:nvSpPr>
-        <p:spPr/>
-        <p:txBody>
-          <a:bodyPr/>
-          <a:lstStyle/>
-          <a:p>
-            <a:fld id="{A02D9A9C-251E-4686-914B-47E3F39F30D8}" type="slidenum">
-              <a:rPr lang="de-DE" smtClean="0"/>
-              <a:t>12</a:t>
-            </a:fld>
-            <a:endParaRPr lang="de-DE"/>
-          </a:p>
-        </p:txBody>
-      </p:sp>
-      <p:pic>
-        <p:nvPicPr>
-          <p:cNvPr id="10" name="Picture 9">
-            <a:extLst>
-              <a:ext uri="{FF2B5EF4-FFF2-40B4-BE49-F238E27FC236}">
-                <a16:creationId xmlns:a16="http://schemas.microsoft.com/office/drawing/2014/main" id="{07CFE9B8-CD85-6E70-E03E-89C4731022DE}"/>
-              </a:ext>
-            </a:extLst>
-          </p:cNvPr>
-          <p:cNvPicPr>
-            <a:picLocks noChangeAspect="1"/>
-          </p:cNvPicPr>
-          <p:nvPr/>
-        </p:nvPicPr>
-        <p:blipFill>
-          <a:blip r:embed="rId2"/>
-          <a:stretch>
-            <a:fillRect/>
-          </a:stretch>
-        </p:blipFill>
-        <p:spPr>
-          <a:xfrm>
-            <a:off x="3881063" y="1095697"/>
-            <a:ext cx="6868274" cy="6868274"/>
-          </a:xfrm>
-          <a:prstGeom prst="rect">
-            <a:avLst/>
-          </a:prstGeom>
-        </p:spPr>
-      </p:pic>
-      <p:sp>
-        <p:nvSpPr>
-          <p:cNvPr id="11" name="TextBox 10">
-            <a:extLst>
-              <a:ext uri="{FF2B5EF4-FFF2-40B4-BE49-F238E27FC236}">
-                <a16:creationId xmlns:a16="http://schemas.microsoft.com/office/drawing/2014/main" id="{F3027F4B-361D-A062-F5BF-7B4E7ED5E83E}"/>
-              </a:ext>
-            </a:extLst>
-          </p:cNvPr>
-          <p:cNvSpPr txBox="1"/>
-          <p:nvPr/>
-        </p:nvSpPr>
-        <p:spPr>
-          <a:xfrm>
-            <a:off x="1252800" y="634032"/>
-            <a:ext cx="9223200" cy="461665"/>
-          </a:xfrm>
-          <a:prstGeom prst="rect">
-            <a:avLst/>
-          </a:prstGeom>
-          <a:noFill/>
-        </p:spPr>
-        <p:txBody>
-          <a:bodyPr wrap="square" rtlCol="0">
-            <a:spAutoFit/>
-          </a:bodyPr>
-          <a:lstStyle/>
-          <a:p>
-            <a:r>
-              <a:rPr lang="en-US" sz="2400" b="1" i="0" dirty="0">
-                <a:effectLst/>
-                <a:latin typeface="Arial" panose="020B0604020202020204" pitchFamily="34" charset="0"/>
-                <a:cs typeface="Arial" panose="020B0604020202020204" pitchFamily="34" charset="0"/>
-              </a:rPr>
-              <a:t>Multiple Runs: </a:t>
-            </a:r>
-            <a:r>
-              <a:rPr lang="en-US" sz="2400" b="1" dirty="0">
-                <a:latin typeface="Arial" panose="020B0604020202020204" pitchFamily="34" charset="0"/>
-                <a:cs typeface="Arial" panose="020B0604020202020204" pitchFamily="34" charset="0"/>
-              </a:rPr>
-              <a:t>Inference</a:t>
-            </a:r>
-            <a:r>
-              <a:rPr lang="en-US" sz="2400" b="1" i="0" dirty="0">
-                <a:effectLst/>
-                <a:latin typeface="Arial" panose="020B0604020202020204" pitchFamily="34" charset="0"/>
-                <a:cs typeface="Arial" panose="020B0604020202020204" pitchFamily="34" charset="0"/>
-              </a:rPr>
-              <a:t> Performance Comparison(reward 1)</a:t>
-            </a:r>
-            <a:endParaRPr lang="de-DE" sz="2400" dirty="0">
-              <a:latin typeface="Arial" panose="020B0604020202020204" pitchFamily="34" charset="0"/>
-              <a:cs typeface="Arial" panose="020B0604020202020204" pitchFamily="34" charset="0"/>
-            </a:endParaRPr>
-          </a:p>
-        </p:txBody>
-      </p:sp>
-    </p:spTree>
-    <p:extLst>
-      <p:ext uri="{BB962C8B-B14F-4D97-AF65-F5344CB8AC3E}">
-        <p14:creationId xmlns:p14="http://schemas.microsoft.com/office/powerpoint/2010/main" val="3881202395"/>
-      </p:ext>
-    </p:extLst>
-  </p:cSld>
-  <p:clrMapOvr>
-    <a:masterClrMapping/>
-  </p:clrMapOvr>
-</p:sld>
-</file>
-
 <file path=ppt/slides/slide13.xml><?xml version="1.0" encoding="utf-8"?>
 <p:sld xmlns:a="http://schemas.openxmlformats.org/drawingml/2006/main" xmlns:r="http://schemas.openxmlformats.org/officeDocument/2006/relationships" xmlns:p="http://schemas.openxmlformats.org/presentationml/2006/main">
   <p:cSld>
@@ -2391,7 +2592,7 @@
           <p:cNvPr id="2" name="Slide Number Placeholder 1">
             <a:extLst>
               <a:ext uri="{FF2B5EF4-FFF2-40B4-BE49-F238E27FC236}">
-                <a16:creationId xmlns:a16="http://schemas.microsoft.com/office/drawing/2014/main" id="{DF6C40E9-89F7-5FA5-96B2-B61769A7075E}"/>
+                <a16:creationId xmlns:a16="http://schemas.microsoft.com/office/drawing/2014/main" id="{0EFD8683-0C60-B51C-39B0-886FFC7863F1}"/>
               </a:ext>
             </a:extLst>
           </p:cNvPr>
@@ -2420,7 +2621,7 @@
           <p:cNvPr id="4" name="Picture 3">
             <a:extLst>
               <a:ext uri="{FF2B5EF4-FFF2-40B4-BE49-F238E27FC236}">
-                <a16:creationId xmlns:a16="http://schemas.microsoft.com/office/drawing/2014/main" id="{79DB60A6-A8E7-DEC7-B095-BD655360E24C}"/>
+                <a16:creationId xmlns:a16="http://schemas.microsoft.com/office/drawing/2014/main" id="{F02F8BFA-7B03-0F03-335C-4F562268FCA6}"/>
               </a:ext>
             </a:extLst>
           </p:cNvPr>
@@ -2437,8 +2638,8 @@
         </p:blipFill>
         <p:spPr>
           <a:xfrm>
-            <a:off x="3768047" y="1023777"/>
-            <a:ext cx="6981290" cy="6981290"/>
+            <a:off x="796247" y="1442803"/>
+            <a:ext cx="13037906" cy="5343994"/>
           </a:xfrm>
           <a:prstGeom prst="rect">
             <a:avLst/>
@@ -2447,10 +2648,10 @@
       </p:pic>
       <p:sp>
         <p:nvSpPr>
-          <p:cNvPr id="6" name="TextBox 5">
-            <a:extLst>
-              <a:ext uri="{FF2B5EF4-FFF2-40B4-BE49-F238E27FC236}">
-                <a16:creationId xmlns:a16="http://schemas.microsoft.com/office/drawing/2014/main" id="{F233CB88-E26B-260D-8442-0829B9912B85}"/>
+          <p:cNvPr id="5" name="TextBox 4">
+            <a:extLst>
+              <a:ext uri="{FF2B5EF4-FFF2-40B4-BE49-F238E27FC236}">
+                <a16:creationId xmlns:a16="http://schemas.microsoft.com/office/drawing/2014/main" id="{4D03FD8E-AE43-26D7-EDED-65C8456F852D}"/>
               </a:ext>
             </a:extLst>
           </p:cNvPr>
@@ -2459,8 +2660,8 @@
         </p:nvSpPr>
         <p:spPr>
           <a:xfrm>
-            <a:off x="1252800" y="634032"/>
-            <a:ext cx="9223200" cy="461665"/>
+            <a:off x="4419503" y="6933146"/>
+            <a:ext cx="5791394" cy="338554"/>
           </a:xfrm>
           <a:prstGeom prst="rect">
             <a:avLst/>
@@ -2468,52 +2669,23 @@
           <a:noFill/>
         </p:spPr>
         <p:txBody>
-          <a:bodyPr wrap="square" rtlCol="0">
+          <a:bodyPr wrap="none" rtlCol="0">
             <a:spAutoFit/>
           </a:bodyPr>
           <a:lstStyle/>
           <a:p>
             <a:r>
-              <a:rPr lang="en-US" sz="2400" b="1" i="0" dirty="0">
-                <a:effectLst/>
-                <a:latin typeface="Arial" panose="020B0604020202020204" pitchFamily="34" charset="0"/>
-                <a:cs typeface="Arial" panose="020B0604020202020204" pitchFamily="34" charset="0"/>
-              </a:rPr>
-              <a:t>Multiple Runs: </a:t>
-            </a:r>
-            <a:r>
-              <a:rPr lang="en-US" sz="2400" b="1" dirty="0">
-                <a:latin typeface="Arial" panose="020B0604020202020204" pitchFamily="34" charset="0"/>
-                <a:cs typeface="Arial" panose="020B0604020202020204" pitchFamily="34" charset="0"/>
-              </a:rPr>
-              <a:t>Inference</a:t>
-            </a:r>
-            <a:r>
-              <a:rPr lang="en-US" sz="2400" b="1" i="0" dirty="0">
-                <a:effectLst/>
-                <a:latin typeface="Arial" panose="020B0604020202020204" pitchFamily="34" charset="0"/>
-                <a:cs typeface="Arial" panose="020B0604020202020204" pitchFamily="34" charset="0"/>
-              </a:rPr>
-              <a:t> Performance Comparison</a:t>
-            </a:r>
-            <a:r>
-              <a:rPr lang="en-US" sz="2400" b="1" dirty="0">
-                <a:latin typeface="Arial" panose="020B0604020202020204" pitchFamily="34" charset="0"/>
-                <a:cs typeface="Arial" panose="020B0604020202020204" pitchFamily="34" charset="0"/>
-              </a:rPr>
-              <a:t> (reward 2)</a:t>
-            </a:r>
-            <a:endParaRPr lang="de-DE" sz="2400" dirty="0">
-              <a:latin typeface="Arial" panose="020B0604020202020204" pitchFamily="34" charset="0"/>
-              <a:cs typeface="Arial" panose="020B0604020202020204" pitchFamily="34" charset="0"/>
-            </a:endParaRPr>
+              <a:rPr lang="en-US" sz="1600" dirty="0"/>
+              <a:t>Fig: Visualization of system dynamics and control for one trajectory.</a:t>
+            </a:r>
+            <a:endParaRPr lang="de-DE" sz="1600" dirty="0"/>
           </a:p>
         </p:txBody>
       </p:sp>
     </p:spTree>
     <p:extLst>
       <p:ext uri="{BB962C8B-B14F-4D97-AF65-F5344CB8AC3E}">
-        <p14:creationId xmlns:p14="http://schemas.microsoft.com/office/powerpoint/2010/main" val="241529522"/>
+        <p14:creationId xmlns:p14="http://schemas.microsoft.com/office/powerpoint/2010/main" val="3753974211"/>
       </p:ext>
     </p:extLst>
   </p:cSld>
@@ -2545,7 +2717,7 @@
           <p:cNvPr id="2" name="Slide Number Placeholder 1">
             <a:extLst>
               <a:ext uri="{FF2B5EF4-FFF2-40B4-BE49-F238E27FC236}">
-                <a16:creationId xmlns:a16="http://schemas.microsoft.com/office/drawing/2014/main" id="{C4B959B7-EFE5-32A3-50D9-D1DB5967DAFC}"/>
+                <a16:creationId xmlns:a16="http://schemas.microsoft.com/office/drawing/2014/main" id="{FD487D02-6950-31EE-9075-CE462E154503}"/>
               </a:ext>
             </a:extLst>
           </p:cNvPr>
@@ -2569,12 +2741,70 @@
           </a:p>
         </p:txBody>
       </p:sp>
+      <p:sp>
+        <p:nvSpPr>
+          <p:cNvPr id="11" name="TextBox 10">
+            <a:extLst>
+              <a:ext uri="{FF2B5EF4-FFF2-40B4-BE49-F238E27FC236}">
+                <a16:creationId xmlns:a16="http://schemas.microsoft.com/office/drawing/2014/main" id="{F3027F4B-361D-A062-F5BF-7B4E7ED5E83E}"/>
+              </a:ext>
+            </a:extLst>
+          </p:cNvPr>
+          <p:cNvSpPr txBox="1"/>
+          <p:nvPr/>
+        </p:nvSpPr>
+        <p:spPr>
+          <a:xfrm>
+            <a:off x="954850" y="172367"/>
+            <a:ext cx="9223200" cy="461665"/>
+          </a:xfrm>
+          <a:prstGeom prst="rect">
+            <a:avLst/>
+          </a:prstGeom>
+          <a:noFill/>
+        </p:spPr>
+        <p:txBody>
+          <a:bodyPr wrap="square" rtlCol="0">
+            <a:spAutoFit/>
+          </a:bodyPr>
+          <a:lstStyle/>
+          <a:p>
+            <a:r>
+              <a:rPr lang="en-US" sz="2400" b="1" i="0" dirty="0">
+                <a:effectLst/>
+                <a:latin typeface="Arial" panose="020B0604020202020204" pitchFamily="34" charset="0"/>
+                <a:cs typeface="Arial" panose="020B0604020202020204" pitchFamily="34" charset="0"/>
+              </a:rPr>
+              <a:t>Multiple Runs: </a:t>
+            </a:r>
+            <a:r>
+              <a:rPr lang="en-US" sz="2400" b="1" dirty="0">
+                <a:latin typeface="Arial" panose="020B0604020202020204" pitchFamily="34" charset="0"/>
+                <a:cs typeface="Arial" panose="020B0604020202020204" pitchFamily="34" charset="0"/>
+              </a:rPr>
+              <a:t>Inference</a:t>
+            </a:r>
+            <a:r>
+              <a:rPr lang="en-US" sz="2400" b="1" i="0" dirty="0">
+                <a:effectLst/>
+                <a:latin typeface="Arial" panose="020B0604020202020204" pitchFamily="34" charset="0"/>
+                <a:cs typeface="Arial" panose="020B0604020202020204" pitchFamily="34" charset="0"/>
+              </a:rPr>
+              <a:t> Performance Comparison</a:t>
+            </a:r>
+            <a:endParaRPr lang="de-DE" sz="2400" dirty="0">
+              <a:latin typeface="Arial" panose="020B0604020202020204" pitchFamily="34" charset="0"/>
+              <a:cs typeface="Arial" panose="020B0604020202020204" pitchFamily="34" charset="0"/>
+            </a:endParaRPr>
+          </a:p>
+        </p:txBody>
+      </p:sp>
       <p:pic>
         <p:nvPicPr>
-          <p:cNvPr id="6" name="Picture 5">
-            <a:extLst>
-              <a:ext uri="{FF2B5EF4-FFF2-40B4-BE49-F238E27FC236}">
-                <a16:creationId xmlns:a16="http://schemas.microsoft.com/office/drawing/2014/main" id="{782C1992-3888-5B47-2E82-A8334E0B851C}"/>
+          <p:cNvPr id="9" name="Picture 8">
+            <a:extLst>
+              <a:ext uri="{FF2B5EF4-FFF2-40B4-BE49-F238E27FC236}">
+                <a16:creationId xmlns:a16="http://schemas.microsoft.com/office/drawing/2014/main" id="{3928F39F-A005-F729-AF8B-736F686388C0}"/>
               </a:ext>
             </a:extLst>
           </p:cNvPr>
@@ -2591,199 +2821,18 @@
         </p:blipFill>
         <p:spPr>
           <a:xfrm>
-            <a:off x="1242165" y="1040481"/>
-            <a:ext cx="12146070" cy="4963218"/>
+            <a:off x="2148740" y="1027365"/>
+            <a:ext cx="10332919" cy="6606130"/>
           </a:xfrm>
           <a:prstGeom prst="rect">
             <a:avLst/>
           </a:prstGeom>
         </p:spPr>
       </p:pic>
-      <p:sp>
-        <p:nvSpPr>
-          <p:cNvPr id="3" name="TextBox 2">
-            <a:extLst>
-              <a:ext uri="{FF2B5EF4-FFF2-40B4-BE49-F238E27FC236}">
-                <a16:creationId xmlns:a16="http://schemas.microsoft.com/office/drawing/2014/main" id="{080535F2-175F-9034-9D06-C073EEBDCAD8}"/>
-              </a:ext>
-            </a:extLst>
-          </p:cNvPr>
-          <p:cNvSpPr txBox="1"/>
-          <p:nvPr/>
-        </p:nvSpPr>
-        <p:spPr>
-          <a:xfrm>
-            <a:off x="1979017" y="6316238"/>
-            <a:ext cx="10672365" cy="1477328"/>
-          </a:xfrm>
-          <a:prstGeom prst="rect">
-            <a:avLst/>
-          </a:prstGeom>
-          <a:noFill/>
-        </p:spPr>
-        <p:txBody>
-          <a:bodyPr wrap="square" rtlCol="0">
-            <a:spAutoFit/>
-          </a:bodyPr>
-          <a:lstStyle/>
-          <a:p>
-            <a:r>
-              <a:rPr lang="en-US" dirty="0"/>
-              <a:t>Fig: Illustration of the investigated industrial energy conversion system for electrified steam generation. The system consists of a HTHP, a TES and a SG, where the HTHP is powered by electricity from a wind turbine or the power grid. The HTHP uses waste heat air stream as a heat source and enables charging and discharging of the TES via an intermediate thermal oil stream. Furthermore, constant heat demand for the steam consumer factory must be satisfied.</a:t>
-            </a:r>
-            <a:endParaRPr lang="de-DE" dirty="0"/>
-          </a:p>
-        </p:txBody>
-      </p:sp>
-      <p:sp>
-        <p:nvSpPr>
-          <p:cNvPr id="4" name="Text 0">
-            <a:extLst>
-              <a:ext uri="{FF2B5EF4-FFF2-40B4-BE49-F238E27FC236}">
-                <a16:creationId xmlns:a16="http://schemas.microsoft.com/office/drawing/2014/main" id="{DE957822-0B68-9DDF-98AA-CFF17F293EF2}"/>
-              </a:ext>
-            </a:extLst>
-          </p:cNvPr>
-          <p:cNvSpPr/>
-          <p:nvPr/>
-        </p:nvSpPr>
-        <p:spPr>
-          <a:xfrm>
-            <a:off x="994906" y="578615"/>
-            <a:ext cx="9858256" cy="485775"/>
-          </a:xfrm>
-          <a:prstGeom prst="rect">
-            <a:avLst/>
-          </a:prstGeom>
-          <a:noFill/>
-          <a:ln/>
-        </p:spPr>
-        <p:txBody>
-          <a:bodyPr wrap="none" lIns="0" tIns="0" rIns="0" bIns="0" rtlCol="0" anchor="t"/>
-          <a:lstStyle>
-            <a:defPPr>
-              <a:defRPr lang="de-DE"/>
-            </a:defPPr>
-            <a:lvl1pPr marL="0" algn="l" defTabSz="914400" rtl="0" eaLnBrk="1" latinLnBrk="0" hangingPunct="1">
-              <a:defRPr sz="1800" kern="1200">
-                <a:solidFill>
-                  <a:schemeClr val="tx1"/>
-                </a:solidFill>
-                <a:latin typeface="+mn-lt"/>
-                <a:ea typeface="+mn-ea"/>
-                <a:cs typeface="+mn-cs"/>
-              </a:defRPr>
-            </a:lvl1pPr>
-            <a:lvl2pPr marL="457200" algn="l" defTabSz="914400" rtl="0" eaLnBrk="1" latinLnBrk="0" hangingPunct="1">
-              <a:defRPr sz="1800" kern="1200">
-                <a:solidFill>
-                  <a:schemeClr val="tx1"/>
-                </a:solidFill>
-                <a:latin typeface="+mn-lt"/>
-                <a:ea typeface="+mn-ea"/>
-                <a:cs typeface="+mn-cs"/>
-              </a:defRPr>
-            </a:lvl2pPr>
-            <a:lvl3pPr marL="914400" algn="l" defTabSz="914400" rtl="0" eaLnBrk="1" latinLnBrk="0" hangingPunct="1">
-              <a:defRPr sz="1800" kern="1200">
-                <a:solidFill>
-                  <a:schemeClr val="tx1"/>
-                </a:solidFill>
-                <a:latin typeface="+mn-lt"/>
-                <a:ea typeface="+mn-ea"/>
-                <a:cs typeface="+mn-cs"/>
-              </a:defRPr>
-            </a:lvl3pPr>
-            <a:lvl4pPr marL="1371600" algn="l" defTabSz="914400" rtl="0" eaLnBrk="1" latinLnBrk="0" hangingPunct="1">
-              <a:defRPr sz="1800" kern="1200">
-                <a:solidFill>
-                  <a:schemeClr val="tx1"/>
-                </a:solidFill>
-                <a:latin typeface="+mn-lt"/>
-                <a:ea typeface="+mn-ea"/>
-                <a:cs typeface="+mn-cs"/>
-              </a:defRPr>
-            </a:lvl4pPr>
-            <a:lvl5pPr marL="1828800" algn="l" defTabSz="914400" rtl="0" eaLnBrk="1" latinLnBrk="0" hangingPunct="1">
-              <a:defRPr sz="1800" kern="1200">
-                <a:solidFill>
-                  <a:schemeClr val="tx1"/>
-                </a:solidFill>
-                <a:latin typeface="+mn-lt"/>
-                <a:ea typeface="+mn-ea"/>
-                <a:cs typeface="+mn-cs"/>
-              </a:defRPr>
-            </a:lvl5pPr>
-            <a:lvl6pPr marL="2286000" algn="l" defTabSz="914400" rtl="0" eaLnBrk="1" latinLnBrk="0" hangingPunct="1">
-              <a:defRPr sz="1800" kern="1200">
-                <a:solidFill>
-                  <a:schemeClr val="tx1"/>
-                </a:solidFill>
-                <a:latin typeface="+mn-lt"/>
-                <a:ea typeface="+mn-ea"/>
-                <a:cs typeface="+mn-cs"/>
-              </a:defRPr>
-            </a:lvl6pPr>
-            <a:lvl7pPr marL="2743200" algn="l" defTabSz="914400" rtl="0" eaLnBrk="1" latinLnBrk="0" hangingPunct="1">
-              <a:defRPr sz="1800" kern="1200">
-                <a:solidFill>
-                  <a:schemeClr val="tx1"/>
-                </a:solidFill>
-                <a:latin typeface="+mn-lt"/>
-                <a:ea typeface="+mn-ea"/>
-                <a:cs typeface="+mn-cs"/>
-              </a:defRPr>
-            </a:lvl7pPr>
-            <a:lvl8pPr marL="3200400" algn="l" defTabSz="914400" rtl="0" eaLnBrk="1" latinLnBrk="0" hangingPunct="1">
-              <a:defRPr sz="1800" kern="1200">
-                <a:solidFill>
-                  <a:schemeClr val="tx1"/>
-                </a:solidFill>
-                <a:latin typeface="+mn-lt"/>
-                <a:ea typeface="+mn-ea"/>
-                <a:cs typeface="+mn-cs"/>
-              </a:defRPr>
-            </a:lvl8pPr>
-            <a:lvl9pPr marL="3657600" algn="l" defTabSz="914400" rtl="0" eaLnBrk="1" latinLnBrk="0" hangingPunct="1">
-              <a:defRPr sz="1800" kern="1200">
-                <a:solidFill>
-                  <a:schemeClr val="tx1"/>
-                </a:solidFill>
-                <a:latin typeface="+mn-lt"/>
-                <a:ea typeface="+mn-ea"/>
-                <a:cs typeface="+mn-cs"/>
-              </a:defRPr>
-            </a:lvl9pPr>
-          </a:lstStyle>
-          <a:p>
-            <a:pPr marL="0" indent="0" algn="l">
-              <a:lnSpc>
-                <a:spcPts val="3800"/>
-              </a:lnSpc>
-              <a:buNone/>
-            </a:pPr>
-            <a:r>
-              <a:rPr lang="en-US" sz="3600" dirty="0">
-                <a:solidFill>
-                  <a:srgbClr val="1B1B27"/>
-                </a:solidFill>
-                <a:latin typeface="Arial" panose="020B0604020202020204" pitchFamily="34" charset="0"/>
-                <a:ea typeface="Alexandria" pitchFamily="34" charset="-122"/>
-                <a:cs typeface="Arial" panose="020B0604020202020204" pitchFamily="34" charset="0"/>
-              </a:rPr>
-              <a:t>Cookie Factory </a:t>
-            </a:r>
-            <a:endParaRPr lang="en-US" sz="3600" dirty="0">
-              <a:latin typeface="Arial" panose="020B0604020202020204" pitchFamily="34" charset="0"/>
-              <a:cs typeface="Arial" panose="020B0604020202020204" pitchFamily="34" charset="0"/>
-            </a:endParaRPr>
-          </a:p>
-        </p:txBody>
-      </p:sp>
     </p:spTree>
     <p:extLst>
       <p:ext uri="{BB962C8B-B14F-4D97-AF65-F5344CB8AC3E}">
-        <p14:creationId xmlns:p14="http://schemas.microsoft.com/office/powerpoint/2010/main" val="2043040984"/>
+        <p14:creationId xmlns:p14="http://schemas.microsoft.com/office/powerpoint/2010/main" val="281696326"/>
       </p:ext>
     </p:extLst>
   </p:cSld>
@@ -2812,10 +2861,106 @@
       </p:grpSpPr>
       <p:sp>
         <p:nvSpPr>
-          <p:cNvPr id="2" name="Slide Number Placeholder 1">
-            <a:extLst>
-              <a:ext uri="{FF2B5EF4-FFF2-40B4-BE49-F238E27FC236}">
-                <a16:creationId xmlns:a16="http://schemas.microsoft.com/office/drawing/2014/main" id="{9A840C5A-C840-A584-A219-DBDFF7A5300B}"/>
+          <p:cNvPr id="2" name="Text 0">
+            <a:extLst>
+              <a:ext uri="{FF2B5EF4-FFF2-40B4-BE49-F238E27FC236}">
+                <a16:creationId xmlns:a16="http://schemas.microsoft.com/office/drawing/2014/main" id="{5E9BDF97-2CEC-5516-F91C-C69A562E04EA}"/>
+              </a:ext>
+            </a:extLst>
+          </p:cNvPr>
+          <p:cNvSpPr/>
+          <p:nvPr/>
+        </p:nvSpPr>
+        <p:spPr>
+          <a:xfrm>
+            <a:off x="793790" y="2643307"/>
+            <a:ext cx="13042821" cy="2126456"/>
+          </a:xfrm>
+          <a:prstGeom prst="rect">
+            <a:avLst/>
+          </a:prstGeom>
+          <a:noFill/>
+          <a:ln/>
+        </p:spPr>
+        <p:txBody>
+          <a:bodyPr wrap="none" lIns="0" tIns="0" rIns="0" bIns="0" rtlCol="0" anchor="t"/>
+          <a:lstStyle/>
+          <a:p>
+            <a:pPr marL="0" indent="0" algn="l">
+              <a:lnSpc>
+                <a:spcPts val="16700"/>
+              </a:lnSpc>
+              <a:buNone/>
+            </a:pPr>
+            <a:r>
+              <a:rPr lang="en-US" sz="13350" dirty="0">
+                <a:latin typeface="Arial" panose="020B0604020202020204" pitchFamily="34" charset="0"/>
+                <a:ea typeface="Crimson Pro Semi Bold" pitchFamily="34" charset="-122"/>
+                <a:cs typeface="Arial" panose="020B0604020202020204" pitchFamily="34" charset="0"/>
+              </a:rPr>
+              <a:t>Thank You!</a:t>
+            </a:r>
+            <a:endParaRPr lang="en-US" sz="13350" dirty="0">
+              <a:latin typeface="Arial" panose="020B0604020202020204" pitchFamily="34" charset="0"/>
+              <a:cs typeface="Arial" panose="020B0604020202020204" pitchFamily="34" charset="0"/>
+            </a:endParaRPr>
+          </a:p>
+        </p:txBody>
+      </p:sp>
+      <p:sp>
+        <p:nvSpPr>
+          <p:cNvPr id="3" name="Text 1">
+            <a:extLst>
+              <a:ext uri="{FF2B5EF4-FFF2-40B4-BE49-F238E27FC236}">
+                <a16:creationId xmlns:a16="http://schemas.microsoft.com/office/drawing/2014/main" id="{162051C1-87FA-AC88-FEC3-B65825AC80B1}"/>
+              </a:ext>
+            </a:extLst>
+          </p:cNvPr>
+          <p:cNvSpPr/>
+          <p:nvPr/>
+        </p:nvSpPr>
+        <p:spPr>
+          <a:xfrm>
+            <a:off x="793790" y="5223391"/>
+            <a:ext cx="13042821" cy="362903"/>
+          </a:xfrm>
+          <a:prstGeom prst="rect">
+            <a:avLst/>
+          </a:prstGeom>
+          <a:noFill/>
+          <a:ln/>
+        </p:spPr>
+        <p:txBody>
+          <a:bodyPr wrap="none" lIns="0" tIns="0" rIns="0" bIns="0" rtlCol="0" anchor="t"/>
+          <a:lstStyle/>
+          <a:p>
+            <a:pPr marL="0" indent="0" algn="l">
+              <a:lnSpc>
+                <a:spcPts val="2850"/>
+              </a:lnSpc>
+              <a:buNone/>
+            </a:pPr>
+            <a:r>
+              <a:rPr lang="en-US" sz="1750" dirty="0">
+                <a:latin typeface="Arial" panose="020B0604020202020204" pitchFamily="34" charset="0"/>
+                <a:ea typeface="Heebo" pitchFamily="34" charset="-122"/>
+                <a:cs typeface="Arial" panose="020B0604020202020204" pitchFamily="34" charset="0"/>
+              </a:rPr>
+              <a:t>I appreciate your time and attention.</a:t>
+            </a:r>
+            <a:endParaRPr lang="en-US" sz="1750" dirty="0">
+              <a:latin typeface="Arial" panose="020B0604020202020204" pitchFamily="34" charset="0"/>
+              <a:cs typeface="Arial" panose="020B0604020202020204" pitchFamily="34" charset="0"/>
+            </a:endParaRPr>
+          </a:p>
+        </p:txBody>
+      </p:sp>
+      <p:sp>
+        <p:nvSpPr>
+          <p:cNvPr id="5" name="Slide Number Placeholder 4">
+            <a:extLst>
+              <a:ext uri="{FF2B5EF4-FFF2-40B4-BE49-F238E27FC236}">
+                <a16:creationId xmlns:a16="http://schemas.microsoft.com/office/drawing/2014/main" id="{09EA9E87-DD33-F803-A787-B1528EFB82A4}"/>
               </a:ext>
             </a:extLst>
           </p:cNvPr>
@@ -2834,6 +2979,335 @@
             <a:fld id="{A02D9A9C-251E-4686-914B-47E3F39F30D8}" type="slidenum">
               <a:rPr lang="de-DE" smtClean="0"/>
               <a:t>15</a:t>
+            </a:fld>
+            <a:endParaRPr lang="de-DE"/>
+          </a:p>
+        </p:txBody>
+      </p:sp>
+    </p:spTree>
+    <p:extLst>
+      <p:ext uri="{BB962C8B-B14F-4D97-AF65-F5344CB8AC3E}">
+        <p14:creationId xmlns:p14="http://schemas.microsoft.com/office/powerpoint/2010/main" val="3645203461"/>
+      </p:ext>
+    </p:extLst>
+  </p:cSld>
+  <p:clrMapOvr>
+    <a:masterClrMapping/>
+  </p:clrMapOvr>
+</p:sld>
+</file>
+
+<file path=ppt/slides/slide16.xml><?xml version="1.0" encoding="utf-8"?>
+<p:sld xmlns:a="http://schemas.openxmlformats.org/drawingml/2006/main" xmlns:r="http://schemas.openxmlformats.org/officeDocument/2006/relationships" xmlns:p="http://schemas.openxmlformats.org/presentationml/2006/main" show="0">
+  <p:cSld>
+    <p:spTree>
+      <p:nvGrpSpPr>
+        <p:cNvPr id="1" name=""/>
+        <p:cNvGrpSpPr/>
+        <p:nvPr/>
+      </p:nvGrpSpPr>
+      <p:grpSpPr>
+        <a:xfrm>
+          <a:off x="0" y="0"/>
+          <a:ext cx="0" cy="0"/>
+          <a:chOff x="0" y="0"/>
+          <a:chExt cx="0" cy="0"/>
+        </a:xfrm>
+      </p:grpSpPr>
+      <p:sp>
+        <p:nvSpPr>
+          <p:cNvPr id="2" name="Slide Number Placeholder 1">
+            <a:extLst>
+              <a:ext uri="{FF2B5EF4-FFF2-40B4-BE49-F238E27FC236}">
+                <a16:creationId xmlns:a16="http://schemas.microsoft.com/office/drawing/2014/main" id="{C4B959B7-EFE5-32A3-50D9-D1DB5967DAFC}"/>
+              </a:ext>
+            </a:extLst>
+          </p:cNvPr>
+          <p:cNvSpPr>
+            <a:spLocks noGrp="1"/>
+          </p:cNvSpPr>
+          <p:nvPr>
+            <p:ph type="sldNum" sz="quarter" idx="10"/>
+          </p:nvPr>
+        </p:nvSpPr>
+        <p:spPr/>
+        <p:txBody>
+          <a:bodyPr/>
+          <a:lstStyle/>
+          <a:p>
+            <a:fld id="{A02D9A9C-251E-4686-914B-47E3F39F30D8}" type="slidenum">
+              <a:rPr lang="de-DE" smtClean="0"/>
+              <a:t>16</a:t>
+            </a:fld>
+            <a:endParaRPr lang="de-DE"/>
+          </a:p>
+        </p:txBody>
+      </p:sp>
+      <p:pic>
+        <p:nvPicPr>
+          <p:cNvPr id="6" name="Picture 5">
+            <a:extLst>
+              <a:ext uri="{FF2B5EF4-FFF2-40B4-BE49-F238E27FC236}">
+                <a16:creationId xmlns:a16="http://schemas.microsoft.com/office/drawing/2014/main" id="{782C1992-3888-5B47-2E82-A8334E0B851C}"/>
+              </a:ext>
+            </a:extLst>
+          </p:cNvPr>
+          <p:cNvPicPr>
+            <a:picLocks noChangeAspect="1"/>
+          </p:cNvPicPr>
+          <p:nvPr/>
+        </p:nvPicPr>
+        <p:blipFill>
+          <a:blip r:embed="rId2"/>
+          <a:stretch>
+            <a:fillRect/>
+          </a:stretch>
+        </p:blipFill>
+        <p:spPr>
+          <a:xfrm>
+            <a:off x="1242165" y="1040481"/>
+            <a:ext cx="12146070" cy="4963218"/>
+          </a:xfrm>
+          <a:prstGeom prst="rect">
+            <a:avLst/>
+          </a:prstGeom>
+        </p:spPr>
+      </p:pic>
+      <p:sp>
+        <p:nvSpPr>
+          <p:cNvPr id="3" name="TextBox 2">
+            <a:extLst>
+              <a:ext uri="{FF2B5EF4-FFF2-40B4-BE49-F238E27FC236}">
+                <a16:creationId xmlns:a16="http://schemas.microsoft.com/office/drawing/2014/main" id="{080535F2-175F-9034-9D06-C073EEBDCAD8}"/>
+              </a:ext>
+            </a:extLst>
+          </p:cNvPr>
+          <p:cNvSpPr txBox="1"/>
+          <p:nvPr/>
+        </p:nvSpPr>
+        <p:spPr>
+          <a:xfrm>
+            <a:off x="1979017" y="6316238"/>
+            <a:ext cx="10672365" cy="1477328"/>
+          </a:xfrm>
+          <a:prstGeom prst="rect">
+            <a:avLst/>
+          </a:prstGeom>
+          <a:noFill/>
+        </p:spPr>
+        <p:txBody>
+          <a:bodyPr wrap="square" rtlCol="0">
+            <a:spAutoFit/>
+          </a:bodyPr>
+          <a:lstStyle/>
+          <a:p>
+            <a:r>
+              <a:rPr lang="en-US" dirty="0"/>
+              <a:t>Fig: Illustration of the investigated industrial energy conversion system for electrified steam generation. The system consists of a HTHP, a TES and a SG, where the HTHP is powered by electricity from a wind turbine or the power grid. The HTHP uses waste heat air stream as a heat source and enables charging and discharging of the TES via an intermediate thermal oil stream. Furthermore, constant heat demand for the steam consumer factory must be satisfied.</a:t>
+            </a:r>
+            <a:endParaRPr lang="de-DE" dirty="0"/>
+          </a:p>
+        </p:txBody>
+      </p:sp>
+      <p:sp>
+        <p:nvSpPr>
+          <p:cNvPr id="4" name="Text 0">
+            <a:extLst>
+              <a:ext uri="{FF2B5EF4-FFF2-40B4-BE49-F238E27FC236}">
+                <a16:creationId xmlns:a16="http://schemas.microsoft.com/office/drawing/2014/main" id="{DE957822-0B68-9DDF-98AA-CFF17F293EF2}"/>
+              </a:ext>
+            </a:extLst>
+          </p:cNvPr>
+          <p:cNvSpPr/>
+          <p:nvPr/>
+        </p:nvSpPr>
+        <p:spPr>
+          <a:xfrm>
+            <a:off x="994906" y="578615"/>
+            <a:ext cx="9858256" cy="485775"/>
+          </a:xfrm>
+          <a:prstGeom prst="rect">
+            <a:avLst/>
+          </a:prstGeom>
+          <a:noFill/>
+          <a:ln/>
+        </p:spPr>
+        <p:txBody>
+          <a:bodyPr wrap="none" lIns="0" tIns="0" rIns="0" bIns="0" rtlCol="0" anchor="t"/>
+          <a:lstStyle>
+            <a:defPPr>
+              <a:defRPr lang="de-DE"/>
+            </a:defPPr>
+            <a:lvl1pPr marL="0" algn="l" defTabSz="914400" rtl="0" eaLnBrk="1" latinLnBrk="0" hangingPunct="1">
+              <a:defRPr sz="1800" kern="1200">
+                <a:solidFill>
+                  <a:schemeClr val="tx1"/>
+                </a:solidFill>
+                <a:latin typeface="+mn-lt"/>
+                <a:ea typeface="+mn-ea"/>
+                <a:cs typeface="+mn-cs"/>
+              </a:defRPr>
+            </a:lvl1pPr>
+            <a:lvl2pPr marL="457200" algn="l" defTabSz="914400" rtl="0" eaLnBrk="1" latinLnBrk="0" hangingPunct="1">
+              <a:defRPr sz="1800" kern="1200">
+                <a:solidFill>
+                  <a:schemeClr val="tx1"/>
+                </a:solidFill>
+                <a:latin typeface="+mn-lt"/>
+                <a:ea typeface="+mn-ea"/>
+                <a:cs typeface="+mn-cs"/>
+              </a:defRPr>
+            </a:lvl2pPr>
+            <a:lvl3pPr marL="914400" algn="l" defTabSz="914400" rtl="0" eaLnBrk="1" latinLnBrk="0" hangingPunct="1">
+              <a:defRPr sz="1800" kern="1200">
+                <a:solidFill>
+                  <a:schemeClr val="tx1"/>
+                </a:solidFill>
+                <a:latin typeface="+mn-lt"/>
+                <a:ea typeface="+mn-ea"/>
+                <a:cs typeface="+mn-cs"/>
+              </a:defRPr>
+            </a:lvl3pPr>
+            <a:lvl4pPr marL="1371600" algn="l" defTabSz="914400" rtl="0" eaLnBrk="1" latinLnBrk="0" hangingPunct="1">
+              <a:defRPr sz="1800" kern="1200">
+                <a:solidFill>
+                  <a:schemeClr val="tx1"/>
+                </a:solidFill>
+                <a:latin typeface="+mn-lt"/>
+                <a:ea typeface="+mn-ea"/>
+                <a:cs typeface="+mn-cs"/>
+              </a:defRPr>
+            </a:lvl4pPr>
+            <a:lvl5pPr marL="1828800" algn="l" defTabSz="914400" rtl="0" eaLnBrk="1" latinLnBrk="0" hangingPunct="1">
+              <a:defRPr sz="1800" kern="1200">
+                <a:solidFill>
+                  <a:schemeClr val="tx1"/>
+                </a:solidFill>
+                <a:latin typeface="+mn-lt"/>
+                <a:ea typeface="+mn-ea"/>
+                <a:cs typeface="+mn-cs"/>
+              </a:defRPr>
+            </a:lvl5pPr>
+            <a:lvl6pPr marL="2286000" algn="l" defTabSz="914400" rtl="0" eaLnBrk="1" latinLnBrk="0" hangingPunct="1">
+              <a:defRPr sz="1800" kern="1200">
+                <a:solidFill>
+                  <a:schemeClr val="tx1"/>
+                </a:solidFill>
+                <a:latin typeface="+mn-lt"/>
+                <a:ea typeface="+mn-ea"/>
+                <a:cs typeface="+mn-cs"/>
+              </a:defRPr>
+            </a:lvl6pPr>
+            <a:lvl7pPr marL="2743200" algn="l" defTabSz="914400" rtl="0" eaLnBrk="1" latinLnBrk="0" hangingPunct="1">
+              <a:defRPr sz="1800" kern="1200">
+                <a:solidFill>
+                  <a:schemeClr val="tx1"/>
+                </a:solidFill>
+                <a:latin typeface="+mn-lt"/>
+                <a:ea typeface="+mn-ea"/>
+                <a:cs typeface="+mn-cs"/>
+              </a:defRPr>
+            </a:lvl7pPr>
+            <a:lvl8pPr marL="3200400" algn="l" defTabSz="914400" rtl="0" eaLnBrk="1" latinLnBrk="0" hangingPunct="1">
+              <a:defRPr sz="1800" kern="1200">
+                <a:solidFill>
+                  <a:schemeClr val="tx1"/>
+                </a:solidFill>
+                <a:latin typeface="+mn-lt"/>
+                <a:ea typeface="+mn-ea"/>
+                <a:cs typeface="+mn-cs"/>
+              </a:defRPr>
+            </a:lvl8pPr>
+            <a:lvl9pPr marL="3657600" algn="l" defTabSz="914400" rtl="0" eaLnBrk="1" latinLnBrk="0" hangingPunct="1">
+              <a:defRPr sz="1800" kern="1200">
+                <a:solidFill>
+                  <a:schemeClr val="tx1"/>
+                </a:solidFill>
+                <a:latin typeface="+mn-lt"/>
+                <a:ea typeface="+mn-ea"/>
+                <a:cs typeface="+mn-cs"/>
+              </a:defRPr>
+            </a:lvl9pPr>
+          </a:lstStyle>
+          <a:p>
+            <a:pPr marL="0" indent="0" algn="l">
+              <a:lnSpc>
+                <a:spcPts val="3800"/>
+              </a:lnSpc>
+              <a:buNone/>
+            </a:pPr>
+            <a:r>
+              <a:rPr lang="en-US" sz="3600" dirty="0">
+                <a:solidFill>
+                  <a:srgbClr val="1B1B27"/>
+                </a:solidFill>
+                <a:latin typeface="Arial" panose="020B0604020202020204" pitchFamily="34" charset="0"/>
+                <a:ea typeface="Alexandria" pitchFamily="34" charset="-122"/>
+                <a:cs typeface="Arial" panose="020B0604020202020204" pitchFamily="34" charset="0"/>
+              </a:rPr>
+              <a:t>Cookie Factory </a:t>
+            </a:r>
+            <a:endParaRPr lang="en-US" sz="3600" dirty="0">
+              <a:latin typeface="Arial" panose="020B0604020202020204" pitchFamily="34" charset="0"/>
+              <a:cs typeface="Arial" panose="020B0604020202020204" pitchFamily="34" charset="0"/>
+            </a:endParaRPr>
+          </a:p>
+        </p:txBody>
+      </p:sp>
+    </p:spTree>
+    <p:extLst>
+      <p:ext uri="{BB962C8B-B14F-4D97-AF65-F5344CB8AC3E}">
+        <p14:creationId xmlns:p14="http://schemas.microsoft.com/office/powerpoint/2010/main" val="2043040984"/>
+      </p:ext>
+    </p:extLst>
+  </p:cSld>
+  <p:clrMapOvr>
+    <a:masterClrMapping/>
+  </p:clrMapOvr>
+</p:sld>
+</file>
+
+<file path=ppt/slides/slide17.xml><?xml version="1.0" encoding="utf-8"?>
+<p:sld xmlns:a="http://schemas.openxmlformats.org/drawingml/2006/main" xmlns:r="http://schemas.openxmlformats.org/officeDocument/2006/relationships" xmlns:p="http://schemas.openxmlformats.org/presentationml/2006/main" show="0">
+  <p:cSld>
+    <p:spTree>
+      <p:nvGrpSpPr>
+        <p:cNvPr id="1" name=""/>
+        <p:cNvGrpSpPr/>
+        <p:nvPr/>
+      </p:nvGrpSpPr>
+      <p:grpSpPr>
+        <a:xfrm>
+          <a:off x="0" y="0"/>
+          <a:ext cx="0" cy="0"/>
+          <a:chOff x="0" y="0"/>
+          <a:chExt cx="0" cy="0"/>
+        </a:xfrm>
+      </p:grpSpPr>
+      <p:sp>
+        <p:nvSpPr>
+          <p:cNvPr id="2" name="Slide Number Placeholder 1">
+            <a:extLst>
+              <a:ext uri="{FF2B5EF4-FFF2-40B4-BE49-F238E27FC236}">
+                <a16:creationId xmlns:a16="http://schemas.microsoft.com/office/drawing/2014/main" id="{9A840C5A-C840-A584-A219-DBDFF7A5300B}"/>
+              </a:ext>
+            </a:extLst>
+          </p:cNvPr>
+          <p:cNvSpPr>
+            <a:spLocks noGrp="1"/>
+          </p:cNvSpPr>
+          <p:nvPr>
+            <p:ph type="sldNum" sz="quarter" idx="10"/>
+          </p:nvPr>
+        </p:nvSpPr>
+        <p:spPr/>
+        <p:txBody>
+          <a:bodyPr/>
+          <a:lstStyle/>
+          <a:p>
+            <a:fld id="{A02D9A9C-251E-4686-914B-47E3F39F30D8}" type="slidenum">
+              <a:rPr lang="de-DE" smtClean="0"/>
+              <a:t>17</a:t>
             </a:fld>
             <a:endParaRPr lang="de-DE"/>
           </a:p>
@@ -3066,8 +3540,8 @@
 </p:sld>
 </file>
 
-<file path=ppt/slides/slide16.xml><?xml version="1.0" encoding="utf-8"?>
-<p:sld xmlns:a="http://schemas.openxmlformats.org/drawingml/2006/main" xmlns:r="http://schemas.openxmlformats.org/officeDocument/2006/relationships" xmlns:p="http://schemas.openxmlformats.org/presentationml/2006/main">
+<file path=ppt/slides/slide18.xml><?xml version="1.0" encoding="utf-8"?>
+<p:sld xmlns:a="http://schemas.openxmlformats.org/drawingml/2006/main" xmlns:r="http://schemas.openxmlformats.org/officeDocument/2006/relationships" xmlns:p="http://schemas.openxmlformats.org/presentationml/2006/main" show="0">
   <p:cSld>
     <p:spTree>
       <p:nvGrpSpPr>
@@ -3109,7 +3583,7 @@
                 <a:latin typeface="Arial" panose="020B0604020202020204" pitchFamily="34" charset="0"/>
                 <a:cs typeface="Arial" panose="020B0604020202020204" pitchFamily="34" charset="0"/>
               </a:rPr>
-              <a:t>16</a:t>
+              <a:t>18</a:t>
             </a:fld>
             <a:endParaRPr lang="de-DE">
               <a:latin typeface="Arial" panose="020B0604020202020204" pitchFamily="34" charset="0"/>
@@ -3785,162 +4259,7 @@
 </p:sld>
 </file>
 
-<file path=ppt/slides/slide17.xml><?xml version="1.0" encoding="utf-8"?>
-<p:sld xmlns:a="http://schemas.openxmlformats.org/drawingml/2006/main" xmlns:r="http://schemas.openxmlformats.org/officeDocument/2006/relationships" xmlns:p="http://schemas.openxmlformats.org/presentationml/2006/main">
-  <p:cSld>
-    <p:spTree>
-      <p:nvGrpSpPr>
-        <p:cNvPr id="1" name=""/>
-        <p:cNvGrpSpPr/>
-        <p:nvPr/>
-      </p:nvGrpSpPr>
-      <p:grpSpPr>
-        <a:xfrm>
-          <a:off x="0" y="0"/>
-          <a:ext cx="0" cy="0"/>
-          <a:chOff x="0" y="0"/>
-          <a:chExt cx="0" cy="0"/>
-        </a:xfrm>
-      </p:grpSpPr>
-      <p:sp>
-        <p:nvSpPr>
-          <p:cNvPr id="2" name="Text 0">
-            <a:extLst>
-              <a:ext uri="{FF2B5EF4-FFF2-40B4-BE49-F238E27FC236}">
-                <a16:creationId xmlns:a16="http://schemas.microsoft.com/office/drawing/2014/main" id="{5E9BDF97-2CEC-5516-F91C-C69A562E04EA}"/>
-              </a:ext>
-            </a:extLst>
-          </p:cNvPr>
-          <p:cNvSpPr/>
-          <p:nvPr/>
-        </p:nvSpPr>
-        <p:spPr>
-          <a:xfrm>
-            <a:off x="793790" y="2643307"/>
-            <a:ext cx="13042821" cy="2126456"/>
-          </a:xfrm>
-          <a:prstGeom prst="rect">
-            <a:avLst/>
-          </a:prstGeom>
-          <a:noFill/>
-          <a:ln/>
-        </p:spPr>
-        <p:txBody>
-          <a:bodyPr wrap="none" lIns="0" tIns="0" rIns="0" bIns="0" rtlCol="0" anchor="t"/>
-          <a:lstStyle/>
-          <a:p>
-            <a:pPr marL="0" indent="0" algn="l">
-              <a:lnSpc>
-                <a:spcPts val="16700"/>
-              </a:lnSpc>
-              <a:buNone/>
-            </a:pPr>
-            <a:r>
-              <a:rPr lang="en-US" sz="13350" dirty="0">
-                <a:latin typeface="Arial" panose="020B0604020202020204" pitchFamily="34" charset="0"/>
-                <a:ea typeface="Crimson Pro Semi Bold" pitchFamily="34" charset="-122"/>
-                <a:cs typeface="Arial" panose="020B0604020202020204" pitchFamily="34" charset="0"/>
-              </a:rPr>
-              <a:t>Thank You!</a:t>
-            </a:r>
-            <a:endParaRPr lang="en-US" sz="13350" dirty="0">
-              <a:latin typeface="Arial" panose="020B0604020202020204" pitchFamily="34" charset="0"/>
-              <a:cs typeface="Arial" panose="020B0604020202020204" pitchFamily="34" charset="0"/>
-            </a:endParaRPr>
-          </a:p>
-        </p:txBody>
-      </p:sp>
-      <p:sp>
-        <p:nvSpPr>
-          <p:cNvPr id="3" name="Text 1">
-            <a:extLst>
-              <a:ext uri="{FF2B5EF4-FFF2-40B4-BE49-F238E27FC236}">
-                <a16:creationId xmlns:a16="http://schemas.microsoft.com/office/drawing/2014/main" id="{162051C1-87FA-AC88-FEC3-B65825AC80B1}"/>
-              </a:ext>
-            </a:extLst>
-          </p:cNvPr>
-          <p:cNvSpPr/>
-          <p:nvPr/>
-        </p:nvSpPr>
-        <p:spPr>
-          <a:xfrm>
-            <a:off x="793790" y="5223391"/>
-            <a:ext cx="13042821" cy="362903"/>
-          </a:xfrm>
-          <a:prstGeom prst="rect">
-            <a:avLst/>
-          </a:prstGeom>
-          <a:noFill/>
-          <a:ln/>
-        </p:spPr>
-        <p:txBody>
-          <a:bodyPr wrap="none" lIns="0" tIns="0" rIns="0" bIns="0" rtlCol="0" anchor="t"/>
-          <a:lstStyle/>
-          <a:p>
-            <a:pPr marL="0" indent="0" algn="l">
-              <a:lnSpc>
-                <a:spcPts val="2850"/>
-              </a:lnSpc>
-              <a:buNone/>
-            </a:pPr>
-            <a:r>
-              <a:rPr lang="en-US" sz="1750" dirty="0">
-                <a:latin typeface="Arial" panose="020B0604020202020204" pitchFamily="34" charset="0"/>
-                <a:ea typeface="Heebo" pitchFamily="34" charset="-122"/>
-                <a:cs typeface="Arial" panose="020B0604020202020204" pitchFamily="34" charset="0"/>
-              </a:rPr>
-              <a:t>I appreciate your time and attention.</a:t>
-            </a:r>
-            <a:endParaRPr lang="en-US" sz="1750" dirty="0">
-              <a:latin typeface="Arial" panose="020B0604020202020204" pitchFamily="34" charset="0"/>
-              <a:cs typeface="Arial" panose="020B0604020202020204" pitchFamily="34" charset="0"/>
-            </a:endParaRPr>
-          </a:p>
-        </p:txBody>
-      </p:sp>
-      <p:sp>
-        <p:nvSpPr>
-          <p:cNvPr id="5" name="Slide Number Placeholder 4">
-            <a:extLst>
-              <a:ext uri="{FF2B5EF4-FFF2-40B4-BE49-F238E27FC236}">
-                <a16:creationId xmlns:a16="http://schemas.microsoft.com/office/drawing/2014/main" id="{09EA9E87-DD33-F803-A787-B1528EFB82A4}"/>
-              </a:ext>
-            </a:extLst>
-          </p:cNvPr>
-          <p:cNvSpPr>
-            <a:spLocks noGrp="1"/>
-          </p:cNvSpPr>
-          <p:nvPr>
-            <p:ph type="sldNum" sz="quarter" idx="10"/>
-          </p:nvPr>
-        </p:nvSpPr>
-        <p:spPr/>
-        <p:txBody>
-          <a:bodyPr/>
-          <a:lstStyle/>
-          <a:p>
-            <a:fld id="{A02D9A9C-251E-4686-914B-47E3F39F30D8}" type="slidenum">
-              <a:rPr lang="de-DE" smtClean="0"/>
-              <a:t>17</a:t>
-            </a:fld>
-            <a:endParaRPr lang="de-DE"/>
-          </a:p>
-        </p:txBody>
-      </p:sp>
-    </p:spTree>
-    <p:extLst>
-      <p:ext uri="{BB962C8B-B14F-4D97-AF65-F5344CB8AC3E}">
-        <p14:creationId xmlns:p14="http://schemas.microsoft.com/office/powerpoint/2010/main" val="3645203461"/>
-      </p:ext>
-    </p:extLst>
-  </p:cSld>
-  <p:clrMapOvr>
-    <a:masterClrMapping/>
-  </p:clrMapOvr>
-</p:sld>
-</file>
-
-<file path=ppt/slides/slide18.xml><?xml version="1.0" encoding="utf-8"?>
+<file path=ppt/slides/slide19.xml><?xml version="1.0" encoding="utf-8"?>
 <p:sld xmlns:a="http://schemas.openxmlformats.org/drawingml/2006/main" xmlns:r="http://schemas.openxmlformats.org/officeDocument/2006/relationships" xmlns:p="http://schemas.openxmlformats.org/presentationml/2006/main" show="0">
   <p:cSld>
     <p:spTree>
@@ -3980,7 +4299,7 @@
           <a:p>
             <a:fld id="{A02D9A9C-251E-4686-914B-47E3F39F30D8}" type="slidenum">
               <a:rPr lang="de-DE" smtClean="0"/>
-              <a:t>18</a:t>
+              <a:t>19</a:t>
             </a:fld>
             <a:endParaRPr lang="de-DE"/>
           </a:p>
@@ -4079,195 +4398,6 @@
     <p:extLst>
       <p:ext uri="{BB962C8B-B14F-4D97-AF65-F5344CB8AC3E}">
         <p14:creationId xmlns:p14="http://schemas.microsoft.com/office/powerpoint/2010/main" val="216380118"/>
-      </p:ext>
-    </p:extLst>
-  </p:cSld>
-  <p:clrMapOvr>
-    <a:masterClrMapping/>
-  </p:clrMapOvr>
-</p:sld>
-</file>
-
-<file path=ppt/slides/slide19.xml><?xml version="1.0" encoding="utf-8"?>
-<p:sld xmlns:a="http://schemas.openxmlformats.org/drawingml/2006/main" xmlns:r="http://schemas.openxmlformats.org/officeDocument/2006/relationships" xmlns:p="http://schemas.openxmlformats.org/presentationml/2006/main" show="0">
-  <p:cSld>
-    <p:spTree>
-      <p:nvGrpSpPr>
-        <p:cNvPr id="1" name=""/>
-        <p:cNvGrpSpPr/>
-        <p:nvPr/>
-      </p:nvGrpSpPr>
-      <p:grpSpPr>
-        <a:xfrm>
-          <a:off x="0" y="0"/>
-          <a:ext cx="0" cy="0"/>
-          <a:chOff x="0" y="0"/>
-          <a:chExt cx="0" cy="0"/>
-        </a:xfrm>
-      </p:grpSpPr>
-      <p:sp>
-        <p:nvSpPr>
-          <p:cNvPr id="2" name="Slide Number Placeholder 1">
-            <a:extLst>
-              <a:ext uri="{FF2B5EF4-FFF2-40B4-BE49-F238E27FC236}">
-                <a16:creationId xmlns:a16="http://schemas.microsoft.com/office/drawing/2014/main" id="{F22F2BCC-B6B0-7E98-E4DC-ADAA9C788C5C}"/>
-              </a:ext>
-            </a:extLst>
-          </p:cNvPr>
-          <p:cNvSpPr>
-            <a:spLocks noGrp="1"/>
-          </p:cNvSpPr>
-          <p:nvPr>
-            <p:ph type="sldNum" sz="quarter" idx="10"/>
-          </p:nvPr>
-        </p:nvSpPr>
-        <p:spPr/>
-        <p:txBody>
-          <a:bodyPr/>
-          <a:lstStyle/>
-          <a:p>
-            <a:fld id="{A02D9A9C-251E-4686-914B-47E3F39F30D8}" type="slidenum">
-              <a:rPr lang="de-DE" smtClean="0"/>
-              <a:t>19</a:t>
-            </a:fld>
-            <a:endParaRPr lang="de-DE"/>
-          </a:p>
-        </p:txBody>
-      </p:sp>
-      <p:pic>
-        <p:nvPicPr>
-          <p:cNvPr id="6" name="Picture 5">
-            <a:extLst>
-              <a:ext uri="{FF2B5EF4-FFF2-40B4-BE49-F238E27FC236}">
-                <a16:creationId xmlns:a16="http://schemas.microsoft.com/office/drawing/2014/main" id="{9483616A-B819-1459-0E49-CA739B8687DD}"/>
-              </a:ext>
-            </a:extLst>
-          </p:cNvPr>
-          <p:cNvPicPr>
-            <a:picLocks noChangeAspect="1"/>
-          </p:cNvPicPr>
-          <p:nvPr/>
-        </p:nvPicPr>
-        <p:blipFill>
-          <a:blip r:embed="rId2"/>
-          <a:stretch>
-            <a:fillRect/>
-          </a:stretch>
-        </p:blipFill>
-        <p:spPr>
-          <a:xfrm>
-            <a:off x="3357687" y="2086501"/>
-            <a:ext cx="7915026" cy="4056597"/>
-          </a:xfrm>
-          <a:prstGeom prst="rect">
-            <a:avLst/>
-          </a:prstGeom>
-        </p:spPr>
-      </p:pic>
-      <p:cxnSp>
-        <p:nvCxnSpPr>
-          <p:cNvPr id="8" name="Straight Arrow Connector 7">
-            <a:extLst>
-              <a:ext uri="{FF2B5EF4-FFF2-40B4-BE49-F238E27FC236}">
-                <a16:creationId xmlns:a16="http://schemas.microsoft.com/office/drawing/2014/main" id="{9AC30367-5094-6F91-AB07-0F004FB116BD}"/>
-              </a:ext>
-            </a:extLst>
-          </p:cNvPr>
-          <p:cNvCxnSpPr>
-            <a:cxnSpLocks/>
-          </p:cNvCxnSpPr>
-          <p:nvPr/>
-        </p:nvCxnSpPr>
-        <p:spPr>
-          <a:xfrm flipV="1">
-            <a:off x="1160980" y="4161035"/>
-            <a:ext cx="2270589" cy="739739"/>
-          </a:xfrm>
-          <a:prstGeom prst="straightConnector1">
-            <a:avLst/>
-          </a:prstGeom>
-          <a:ln w="38100">
-            <a:tailEnd type="triangle"/>
-          </a:ln>
-        </p:spPr>
-        <p:style>
-          <a:lnRef idx="1">
-            <a:schemeClr val="accent6"/>
-          </a:lnRef>
-          <a:fillRef idx="0">
-            <a:schemeClr val="accent6"/>
-          </a:fillRef>
-          <a:effectRef idx="0">
-            <a:schemeClr val="accent6"/>
-          </a:effectRef>
-          <a:fontRef idx="minor">
-            <a:schemeClr val="tx1"/>
-          </a:fontRef>
-        </p:style>
-      </p:cxnSp>
-      <p:sp>
-        <p:nvSpPr>
-          <p:cNvPr id="13" name="TextBox 12">
-            <a:extLst>
-              <a:ext uri="{FF2B5EF4-FFF2-40B4-BE49-F238E27FC236}">
-                <a16:creationId xmlns:a16="http://schemas.microsoft.com/office/drawing/2014/main" id="{4C7EFE59-B507-A217-C4AC-C4629E6BBE9D}"/>
-              </a:ext>
-            </a:extLst>
-          </p:cNvPr>
-          <p:cNvSpPr txBox="1"/>
-          <p:nvPr/>
-        </p:nvSpPr>
-        <p:spPr>
-          <a:xfrm>
-            <a:off x="1252800" y="634032"/>
-            <a:ext cx="9223200" cy="461665"/>
-          </a:xfrm>
-          <a:prstGeom prst="rect">
-            <a:avLst/>
-          </a:prstGeom>
-          <a:noFill/>
-        </p:spPr>
-        <p:txBody>
-          <a:bodyPr wrap="square" rtlCol="0">
-            <a:spAutoFit/>
-          </a:bodyPr>
-          <a:lstStyle/>
-          <a:p>
-            <a:r>
-              <a:rPr lang="de-DE" sz="2400" dirty="0" err="1">
-                <a:latin typeface="Arial" panose="020B0604020202020204" pitchFamily="34" charset="0"/>
-                <a:cs typeface="Arial" panose="020B0604020202020204" pitchFamily="34" charset="0"/>
-              </a:rPr>
-              <a:t>Reward</a:t>
-            </a:r>
-            <a:r>
-              <a:rPr lang="de-DE" sz="2400" dirty="0">
-                <a:latin typeface="Arial" panose="020B0604020202020204" pitchFamily="34" charset="0"/>
-                <a:cs typeface="Arial" panose="020B0604020202020204" pitchFamily="34" charset="0"/>
-              </a:rPr>
-              <a:t> Shaping- </a:t>
-            </a:r>
-            <a:r>
-              <a:rPr lang="de-DE" sz="2400" dirty="0" err="1">
-                <a:latin typeface="Arial" panose="020B0604020202020204" pitchFamily="34" charset="0"/>
-                <a:cs typeface="Arial" panose="020B0604020202020204" pitchFamily="34" charset="0"/>
-              </a:rPr>
-              <a:t>reward</a:t>
-            </a:r>
-            <a:r>
-              <a:rPr lang="de-DE" sz="2400" dirty="0">
-                <a:latin typeface="Arial" panose="020B0604020202020204" pitchFamily="34" charset="0"/>
-                <a:cs typeface="Arial" panose="020B0604020202020204" pitchFamily="34" charset="0"/>
-              </a:rPr>
-              <a:t> 2</a:t>
-            </a:r>
-          </a:p>
-        </p:txBody>
-      </p:sp>
-    </p:spTree>
-    <p:extLst>
-      <p:ext uri="{BB962C8B-B14F-4D97-AF65-F5344CB8AC3E}">
-        <p14:creationId xmlns:p14="http://schemas.microsoft.com/office/powerpoint/2010/main" val="1609710947"/>
       </p:ext>
     </p:extLst>
   </p:cSld>
@@ -6169,6 +6299,195 @@
       </p:grpSpPr>
       <p:sp>
         <p:nvSpPr>
+          <p:cNvPr id="2" name="Slide Number Placeholder 1">
+            <a:extLst>
+              <a:ext uri="{FF2B5EF4-FFF2-40B4-BE49-F238E27FC236}">
+                <a16:creationId xmlns:a16="http://schemas.microsoft.com/office/drawing/2014/main" id="{F22F2BCC-B6B0-7E98-E4DC-ADAA9C788C5C}"/>
+              </a:ext>
+            </a:extLst>
+          </p:cNvPr>
+          <p:cNvSpPr>
+            <a:spLocks noGrp="1"/>
+          </p:cNvSpPr>
+          <p:nvPr>
+            <p:ph type="sldNum" sz="quarter" idx="10"/>
+          </p:nvPr>
+        </p:nvSpPr>
+        <p:spPr/>
+        <p:txBody>
+          <a:bodyPr/>
+          <a:lstStyle/>
+          <a:p>
+            <a:fld id="{A02D9A9C-251E-4686-914B-47E3F39F30D8}" type="slidenum">
+              <a:rPr lang="de-DE" smtClean="0"/>
+              <a:t>20</a:t>
+            </a:fld>
+            <a:endParaRPr lang="de-DE"/>
+          </a:p>
+        </p:txBody>
+      </p:sp>
+      <p:pic>
+        <p:nvPicPr>
+          <p:cNvPr id="6" name="Picture 5">
+            <a:extLst>
+              <a:ext uri="{FF2B5EF4-FFF2-40B4-BE49-F238E27FC236}">
+                <a16:creationId xmlns:a16="http://schemas.microsoft.com/office/drawing/2014/main" id="{9483616A-B819-1459-0E49-CA739B8687DD}"/>
+              </a:ext>
+            </a:extLst>
+          </p:cNvPr>
+          <p:cNvPicPr>
+            <a:picLocks noChangeAspect="1"/>
+          </p:cNvPicPr>
+          <p:nvPr/>
+        </p:nvPicPr>
+        <p:blipFill>
+          <a:blip r:embed="rId2"/>
+          <a:stretch>
+            <a:fillRect/>
+          </a:stretch>
+        </p:blipFill>
+        <p:spPr>
+          <a:xfrm>
+            <a:off x="3357687" y="2086501"/>
+            <a:ext cx="7915026" cy="4056597"/>
+          </a:xfrm>
+          <a:prstGeom prst="rect">
+            <a:avLst/>
+          </a:prstGeom>
+        </p:spPr>
+      </p:pic>
+      <p:cxnSp>
+        <p:nvCxnSpPr>
+          <p:cNvPr id="8" name="Straight Arrow Connector 7">
+            <a:extLst>
+              <a:ext uri="{FF2B5EF4-FFF2-40B4-BE49-F238E27FC236}">
+                <a16:creationId xmlns:a16="http://schemas.microsoft.com/office/drawing/2014/main" id="{9AC30367-5094-6F91-AB07-0F004FB116BD}"/>
+              </a:ext>
+            </a:extLst>
+          </p:cNvPr>
+          <p:cNvCxnSpPr>
+            <a:cxnSpLocks/>
+          </p:cNvCxnSpPr>
+          <p:nvPr/>
+        </p:nvCxnSpPr>
+        <p:spPr>
+          <a:xfrm flipV="1">
+            <a:off x="1160980" y="4161035"/>
+            <a:ext cx="2270589" cy="739739"/>
+          </a:xfrm>
+          <a:prstGeom prst="straightConnector1">
+            <a:avLst/>
+          </a:prstGeom>
+          <a:ln w="38100">
+            <a:tailEnd type="triangle"/>
+          </a:ln>
+        </p:spPr>
+        <p:style>
+          <a:lnRef idx="1">
+            <a:schemeClr val="accent6"/>
+          </a:lnRef>
+          <a:fillRef idx="0">
+            <a:schemeClr val="accent6"/>
+          </a:fillRef>
+          <a:effectRef idx="0">
+            <a:schemeClr val="accent6"/>
+          </a:effectRef>
+          <a:fontRef idx="minor">
+            <a:schemeClr val="tx1"/>
+          </a:fontRef>
+        </p:style>
+      </p:cxnSp>
+      <p:sp>
+        <p:nvSpPr>
+          <p:cNvPr id="13" name="TextBox 12">
+            <a:extLst>
+              <a:ext uri="{FF2B5EF4-FFF2-40B4-BE49-F238E27FC236}">
+                <a16:creationId xmlns:a16="http://schemas.microsoft.com/office/drawing/2014/main" id="{4C7EFE59-B507-A217-C4AC-C4629E6BBE9D}"/>
+              </a:ext>
+            </a:extLst>
+          </p:cNvPr>
+          <p:cNvSpPr txBox="1"/>
+          <p:nvPr/>
+        </p:nvSpPr>
+        <p:spPr>
+          <a:xfrm>
+            <a:off x="1252800" y="634032"/>
+            <a:ext cx="9223200" cy="461665"/>
+          </a:xfrm>
+          <a:prstGeom prst="rect">
+            <a:avLst/>
+          </a:prstGeom>
+          <a:noFill/>
+        </p:spPr>
+        <p:txBody>
+          <a:bodyPr wrap="square" rtlCol="0">
+            <a:spAutoFit/>
+          </a:bodyPr>
+          <a:lstStyle/>
+          <a:p>
+            <a:r>
+              <a:rPr lang="de-DE" sz="2400" dirty="0" err="1">
+                <a:latin typeface="Arial" panose="020B0604020202020204" pitchFamily="34" charset="0"/>
+                <a:cs typeface="Arial" panose="020B0604020202020204" pitchFamily="34" charset="0"/>
+              </a:rPr>
+              <a:t>Reward</a:t>
+            </a:r>
+            <a:r>
+              <a:rPr lang="de-DE" sz="2400" dirty="0">
+                <a:latin typeface="Arial" panose="020B0604020202020204" pitchFamily="34" charset="0"/>
+                <a:cs typeface="Arial" panose="020B0604020202020204" pitchFamily="34" charset="0"/>
+              </a:rPr>
+              <a:t> Shaping- </a:t>
+            </a:r>
+            <a:r>
+              <a:rPr lang="de-DE" sz="2400" dirty="0" err="1">
+                <a:latin typeface="Arial" panose="020B0604020202020204" pitchFamily="34" charset="0"/>
+                <a:cs typeface="Arial" panose="020B0604020202020204" pitchFamily="34" charset="0"/>
+              </a:rPr>
+              <a:t>reward</a:t>
+            </a:r>
+            <a:r>
+              <a:rPr lang="de-DE" sz="2400" dirty="0">
+                <a:latin typeface="Arial" panose="020B0604020202020204" pitchFamily="34" charset="0"/>
+                <a:cs typeface="Arial" panose="020B0604020202020204" pitchFamily="34" charset="0"/>
+              </a:rPr>
+              <a:t> 2</a:t>
+            </a:r>
+          </a:p>
+        </p:txBody>
+      </p:sp>
+    </p:spTree>
+    <p:extLst>
+      <p:ext uri="{BB962C8B-B14F-4D97-AF65-F5344CB8AC3E}">
+        <p14:creationId xmlns:p14="http://schemas.microsoft.com/office/powerpoint/2010/main" val="1609710947"/>
+      </p:ext>
+    </p:extLst>
+  </p:cSld>
+  <p:clrMapOvr>
+    <a:masterClrMapping/>
+  </p:clrMapOvr>
+</p:sld>
+</file>
+
+<file path=ppt/slides/slide21.xml><?xml version="1.0" encoding="utf-8"?>
+<p:sld xmlns:a="http://schemas.openxmlformats.org/drawingml/2006/main" xmlns:r="http://schemas.openxmlformats.org/officeDocument/2006/relationships" xmlns:p="http://schemas.openxmlformats.org/presentationml/2006/main" show="0">
+  <p:cSld>
+    <p:spTree>
+      <p:nvGrpSpPr>
+        <p:cNvPr id="1" name=""/>
+        <p:cNvGrpSpPr/>
+        <p:nvPr/>
+      </p:nvGrpSpPr>
+      <p:grpSpPr>
+        <a:xfrm>
+          <a:off x="0" y="0"/>
+          <a:ext cx="0" cy="0"/>
+          <a:chOff x="0" y="0"/>
+          <a:chExt cx="0" cy="0"/>
+        </a:xfrm>
+      </p:grpSpPr>
+      <p:sp>
+        <p:nvSpPr>
           <p:cNvPr id="3" name="TextBox 2">
             <a:extLst>
               <a:ext uri="{FF2B5EF4-FFF2-40B4-BE49-F238E27FC236}">
@@ -6575,7 +6894,7 @@
           <a:p>
             <a:fld id="{A02D9A9C-251E-4686-914B-47E3F39F30D8}" type="slidenum">
               <a:rPr lang="de-DE" smtClean="0"/>
-              <a:t>20</a:t>
+              <a:t>21</a:t>
             </a:fld>
             <a:endParaRPr lang="de-DE"/>
           </a:p>
@@ -14809,6 +15128,290 @@
       </p:grpSpPr>
       <p:sp>
         <p:nvSpPr>
+          <p:cNvPr id="2" name="Slide Number Placeholder 1">
+            <a:extLst>
+              <a:ext uri="{FF2B5EF4-FFF2-40B4-BE49-F238E27FC236}">
+                <a16:creationId xmlns:a16="http://schemas.microsoft.com/office/drawing/2014/main" id="{BAA48312-B207-E549-5CFC-D8A89C9494D5}"/>
+              </a:ext>
+            </a:extLst>
+          </p:cNvPr>
+          <p:cNvSpPr>
+            <a:spLocks noGrp="1"/>
+          </p:cNvSpPr>
+          <p:nvPr>
+            <p:ph type="sldNum" sz="quarter" idx="10"/>
+          </p:nvPr>
+        </p:nvSpPr>
+        <p:spPr/>
+        <p:txBody>
+          <a:bodyPr/>
+          <a:lstStyle/>
+          <a:p>
+            <a:fld id="{A02D9A9C-251E-4686-914B-47E3F39F30D8}" type="slidenum">
+              <a:rPr lang="de-DE" smtClean="0">
+                <a:latin typeface="Arial" panose="020B0604020202020204" pitchFamily="34" charset="0"/>
+                <a:cs typeface="Arial" panose="020B0604020202020204" pitchFamily="34" charset="0"/>
+              </a:rPr>
+              <a:t>6</a:t>
+            </a:fld>
+            <a:endParaRPr lang="de-DE">
+              <a:latin typeface="Arial" panose="020B0604020202020204" pitchFamily="34" charset="0"/>
+              <a:cs typeface="Arial" panose="020B0604020202020204" pitchFamily="34" charset="0"/>
+            </a:endParaRPr>
+          </a:p>
+        </p:txBody>
+      </p:sp>
+      <p:pic>
+        <p:nvPicPr>
+          <p:cNvPr id="6" name="Picture 5">
+            <a:extLst>
+              <a:ext uri="{FF2B5EF4-FFF2-40B4-BE49-F238E27FC236}">
+                <a16:creationId xmlns:a16="http://schemas.microsoft.com/office/drawing/2014/main" id="{EE407536-61E1-7C66-0652-74EE0BE26B55}"/>
+              </a:ext>
+            </a:extLst>
+          </p:cNvPr>
+          <p:cNvPicPr>
+            <a:picLocks noChangeAspect="1"/>
+          </p:cNvPicPr>
+          <p:nvPr/>
+        </p:nvPicPr>
+        <p:blipFill>
+          <a:blip r:embed="rId2"/>
+          <a:stretch>
+            <a:fillRect/>
+          </a:stretch>
+        </p:blipFill>
+        <p:spPr>
+          <a:xfrm>
+            <a:off x="339050" y="4499349"/>
+            <a:ext cx="6480000" cy="3389722"/>
+          </a:xfrm>
+          <a:prstGeom prst="rect">
+            <a:avLst/>
+          </a:prstGeom>
+        </p:spPr>
+      </p:pic>
+      <p:pic>
+        <p:nvPicPr>
+          <p:cNvPr id="8" name="Picture 7">
+            <a:extLst>
+              <a:ext uri="{FF2B5EF4-FFF2-40B4-BE49-F238E27FC236}">
+                <a16:creationId xmlns:a16="http://schemas.microsoft.com/office/drawing/2014/main" id="{356F4251-F1C0-634C-97EE-B65EEEFE1EBD}"/>
+              </a:ext>
+            </a:extLst>
+          </p:cNvPr>
+          <p:cNvPicPr>
+            <a:picLocks noChangeAspect="1"/>
+          </p:cNvPicPr>
+          <p:nvPr/>
+        </p:nvPicPr>
+        <p:blipFill>
+          <a:blip r:embed="rId3"/>
+          <a:stretch>
+            <a:fillRect/>
+          </a:stretch>
+        </p:blipFill>
+        <p:spPr>
+          <a:xfrm>
+            <a:off x="339050" y="863051"/>
+            <a:ext cx="6480000" cy="3126211"/>
+          </a:xfrm>
+          <a:prstGeom prst="rect">
+            <a:avLst/>
+          </a:prstGeom>
+        </p:spPr>
+      </p:pic>
+      <p:pic>
+        <p:nvPicPr>
+          <p:cNvPr id="12" name="Picture 11">
+            <a:extLst>
+              <a:ext uri="{FF2B5EF4-FFF2-40B4-BE49-F238E27FC236}">
+                <a16:creationId xmlns:a16="http://schemas.microsoft.com/office/drawing/2014/main" id="{D483F423-DA30-766A-EADC-E01E0515071D}"/>
+              </a:ext>
+            </a:extLst>
+          </p:cNvPr>
+          <p:cNvPicPr>
+            <a:picLocks noChangeAspect="1"/>
+          </p:cNvPicPr>
+          <p:nvPr/>
+        </p:nvPicPr>
+        <p:blipFill>
+          <a:blip r:embed="rId4"/>
+          <a:stretch>
+            <a:fillRect/>
+          </a:stretch>
+        </p:blipFill>
+        <p:spPr>
+          <a:xfrm>
+            <a:off x="7315200" y="1109627"/>
+            <a:ext cx="6902573" cy="6408000"/>
+          </a:xfrm>
+          <a:prstGeom prst="rect">
+            <a:avLst/>
+          </a:prstGeom>
+        </p:spPr>
+      </p:pic>
+      <p:sp>
+        <p:nvSpPr>
+          <p:cNvPr id="13" name="TextBox 12">
+            <a:extLst>
+              <a:ext uri="{FF2B5EF4-FFF2-40B4-BE49-F238E27FC236}">
+                <a16:creationId xmlns:a16="http://schemas.microsoft.com/office/drawing/2014/main" id="{AFBC365D-07E4-5BE3-D31F-A690855F1A89}"/>
+              </a:ext>
+            </a:extLst>
+          </p:cNvPr>
+          <p:cNvSpPr txBox="1"/>
+          <p:nvPr/>
+        </p:nvSpPr>
+        <p:spPr>
+          <a:xfrm>
+            <a:off x="787591" y="3958844"/>
+            <a:ext cx="6031459" cy="276999"/>
+          </a:xfrm>
+          <a:prstGeom prst="rect">
+            <a:avLst/>
+          </a:prstGeom>
+          <a:noFill/>
+        </p:spPr>
+        <p:txBody>
+          <a:bodyPr wrap="none" rtlCol="0">
+            <a:spAutoFit/>
+          </a:bodyPr>
+          <a:lstStyle/>
+          <a:p>
+            <a:r>
+              <a:rPr lang="en-US" sz="1200" b="0" i="0" dirty="0">
+                <a:effectLst/>
+                <a:latin typeface="Arial" panose="020B0604020202020204" pitchFamily="34" charset="0"/>
+                <a:cs typeface="Arial" panose="020B0604020202020204" pitchFamily="34" charset="0"/>
+              </a:rPr>
+              <a:t>Fig. 1: Charging and discharging activation gates with a small deadband around u = 0.</a:t>
+            </a:r>
+            <a:endParaRPr lang="de-DE" sz="1200" dirty="0">
+              <a:latin typeface="Arial" panose="020B0604020202020204" pitchFamily="34" charset="0"/>
+              <a:cs typeface="Arial" panose="020B0604020202020204" pitchFamily="34" charset="0"/>
+            </a:endParaRPr>
+          </a:p>
+        </p:txBody>
+      </p:sp>
+      <p:sp>
+        <p:nvSpPr>
+          <p:cNvPr id="14" name="TextBox 13">
+            <a:extLst>
+              <a:ext uri="{FF2B5EF4-FFF2-40B4-BE49-F238E27FC236}">
+                <a16:creationId xmlns:a16="http://schemas.microsoft.com/office/drawing/2014/main" id="{9904FD2E-D79B-B2AF-FC2F-8F254FD3FFB5}"/>
+              </a:ext>
+            </a:extLst>
+          </p:cNvPr>
+          <p:cNvSpPr txBox="1"/>
+          <p:nvPr/>
+        </p:nvSpPr>
+        <p:spPr>
+          <a:xfrm>
+            <a:off x="7895596" y="7494995"/>
+            <a:ext cx="6163419" cy="276999"/>
+          </a:xfrm>
+          <a:prstGeom prst="rect">
+            <a:avLst/>
+          </a:prstGeom>
+          <a:noFill/>
+        </p:spPr>
+        <p:txBody>
+          <a:bodyPr wrap="none" rtlCol="0">
+            <a:spAutoFit/>
+          </a:bodyPr>
+          <a:lstStyle/>
+          <a:p>
+            <a:r>
+              <a:rPr lang="en-US" sz="1200" b="0" i="0" dirty="0">
+                <a:effectLst/>
+                <a:latin typeface="Arial" panose="020B0604020202020204" pitchFamily="34" charset="0"/>
+                <a:cs typeface="Arial" panose="020B0604020202020204" pitchFamily="34" charset="0"/>
+              </a:rPr>
+              <a:t>Fig. 3: SOC boundary behavior, suppressing discharge near empty and charge near full.</a:t>
+            </a:r>
+            <a:endParaRPr lang="de-DE" sz="1200" dirty="0">
+              <a:latin typeface="Arial" panose="020B0604020202020204" pitchFamily="34" charset="0"/>
+              <a:cs typeface="Arial" panose="020B0604020202020204" pitchFamily="34" charset="0"/>
+            </a:endParaRPr>
+          </a:p>
+        </p:txBody>
+      </p:sp>
+      <p:sp>
+        <p:nvSpPr>
+          <p:cNvPr id="15" name="TextBox 14">
+            <a:extLst>
+              <a:ext uri="{FF2B5EF4-FFF2-40B4-BE49-F238E27FC236}">
+                <a16:creationId xmlns:a16="http://schemas.microsoft.com/office/drawing/2014/main" id="{91E8537B-9D1B-5D9B-91A9-6CE1E75ED4BF}"/>
+              </a:ext>
+            </a:extLst>
+          </p:cNvPr>
+          <p:cNvSpPr txBox="1"/>
+          <p:nvPr/>
+        </p:nvSpPr>
+        <p:spPr>
+          <a:xfrm>
+            <a:off x="1339494" y="7835210"/>
+            <a:ext cx="4479111" cy="261610"/>
+          </a:xfrm>
+          <a:prstGeom prst="rect">
+            <a:avLst/>
+          </a:prstGeom>
+          <a:noFill/>
+        </p:spPr>
+        <p:txBody>
+          <a:bodyPr wrap="none" rtlCol="0">
+            <a:spAutoFit/>
+          </a:bodyPr>
+          <a:lstStyle/>
+          <a:p>
+            <a:r>
+              <a:rPr lang="en-US" sz="1100" b="0" i="0" dirty="0">
+                <a:effectLst/>
+                <a:latin typeface="Arial" panose="020B0604020202020204" pitchFamily="34" charset="0"/>
+                <a:cs typeface="Arial" panose="020B0604020202020204" pitchFamily="34" charset="0"/>
+              </a:rPr>
+              <a:t>Fig. 2: Effect of k and epsilon on gate sharpness and threshold shift.</a:t>
+            </a:r>
+            <a:endParaRPr lang="de-DE" sz="1100" dirty="0">
+              <a:latin typeface="Arial" panose="020B0604020202020204" pitchFamily="34" charset="0"/>
+              <a:cs typeface="Arial" panose="020B0604020202020204" pitchFamily="34" charset="0"/>
+            </a:endParaRPr>
+          </a:p>
+        </p:txBody>
+      </p:sp>
+    </p:spTree>
+    <p:extLst>
+      <p:ext uri="{BB962C8B-B14F-4D97-AF65-F5344CB8AC3E}">
+        <p14:creationId xmlns:p14="http://schemas.microsoft.com/office/powerpoint/2010/main" val="986550675"/>
+      </p:ext>
+    </p:extLst>
+  </p:cSld>
+  <p:clrMapOvr>
+    <a:masterClrMapping/>
+  </p:clrMapOvr>
+</p:sld>
+</file>
+
+<file path=ppt/slides/slide7.xml><?xml version="1.0" encoding="utf-8"?>
+<p:sld xmlns:a="http://schemas.openxmlformats.org/drawingml/2006/main" xmlns:r="http://schemas.openxmlformats.org/officeDocument/2006/relationships" xmlns:p="http://schemas.openxmlformats.org/presentationml/2006/main">
+  <p:cSld>
+    <p:spTree>
+      <p:nvGrpSpPr>
+        <p:cNvPr id="1" name=""/>
+        <p:cNvGrpSpPr/>
+        <p:nvPr/>
+      </p:nvGrpSpPr>
+      <p:grpSpPr>
+        <a:xfrm>
+          <a:off x="0" y="0"/>
+          <a:ext cx="0" cy="0"/>
+          <a:chOff x="0" y="0"/>
+          <a:chExt cx="0" cy="0"/>
+        </a:xfrm>
+      </p:grpSpPr>
+      <p:sp>
+        <p:nvSpPr>
           <p:cNvPr id="17" name="Shape 4">
             <a:extLst>
               <a:ext uri="{FF2B5EF4-FFF2-40B4-BE49-F238E27FC236}">
@@ -16656,7 +17259,7 @@
           <a:p>
             <a:fld id="{A02D9A9C-251E-4686-914B-47E3F39F30D8}" type="slidenum">
               <a:rPr lang="de-DE" smtClean="0"/>
-              <a:t>6</a:t>
+              <a:t>7</a:t>
             </a:fld>
             <a:endParaRPr lang="de-DE"/>
           </a:p>
@@ -16675,7 +17278,7 @@
 </p:sld>
 </file>
 
-<file path=ppt/slides/slide7.xml><?xml version="1.0" encoding="utf-8"?>
+<file path=ppt/slides/slide8.xml><?xml version="1.0" encoding="utf-8"?>
 <p:sld xmlns:a="http://schemas.openxmlformats.org/drawingml/2006/main" xmlns:r="http://schemas.openxmlformats.org/officeDocument/2006/relationships" xmlns:p="http://schemas.openxmlformats.org/presentationml/2006/main">
   <p:cSld>
     <p:spTree>
@@ -16718,7 +17321,7 @@
                 <a:latin typeface="Arial" panose="020B0604020202020204" pitchFamily="34" charset="0"/>
                 <a:cs typeface="Arial" panose="020B0604020202020204" pitchFamily="34" charset="0"/>
               </a:rPr>
-              <a:t>7</a:t>
+              <a:t>8</a:t>
             </a:fld>
             <a:endParaRPr lang="de-DE">
               <a:latin typeface="Arial" panose="020B0604020202020204" pitchFamily="34" charset="0"/>
@@ -17848,7 +18451,7 @@
 </p:sld>
 </file>
 
-<file path=ppt/slides/slide8.xml><?xml version="1.0" encoding="utf-8"?>
+<file path=ppt/slides/slide9.xml><?xml version="1.0" encoding="utf-8"?>
 <p:sld xmlns:a="http://schemas.openxmlformats.org/drawingml/2006/main" xmlns:r="http://schemas.openxmlformats.org/officeDocument/2006/relationships" xmlns:p="http://schemas.openxmlformats.org/presentationml/2006/main">
   <p:cSld>
     <p:spTree>
@@ -18025,7 +18628,7 @@
           <a:p>
             <a:fld id="{A02D9A9C-251E-4686-914B-47E3F39F30D8}" type="slidenum">
               <a:rPr lang="de-DE" smtClean="0"/>
-              <a:t>8</a:t>
+              <a:t>9</a:t>
             </a:fld>
             <a:endParaRPr lang="de-DE"/>
           </a:p>
@@ -18065,353 +18668,6 @@
     <p:extLst>
       <p:ext uri="{BB962C8B-B14F-4D97-AF65-F5344CB8AC3E}">
         <p14:creationId xmlns:p14="http://schemas.microsoft.com/office/powerpoint/2010/main" val="444764384"/>
-      </p:ext>
-    </p:extLst>
-  </p:cSld>
-  <p:clrMapOvr>
-    <a:masterClrMapping/>
-  </p:clrMapOvr>
-</p:sld>
-</file>
-
-<file path=ppt/slides/slide9.xml><?xml version="1.0" encoding="utf-8"?>
-<p:sld xmlns:a="http://schemas.openxmlformats.org/drawingml/2006/main" xmlns:r="http://schemas.openxmlformats.org/officeDocument/2006/relationships" xmlns:p="http://schemas.openxmlformats.org/presentationml/2006/main">
-  <p:cSld>
-    <p:spTree>
-      <p:nvGrpSpPr>
-        <p:cNvPr id="1" name=""/>
-        <p:cNvGrpSpPr/>
-        <p:nvPr/>
-      </p:nvGrpSpPr>
-      <p:grpSpPr>
-        <a:xfrm>
-          <a:off x="0" y="0"/>
-          <a:ext cx="0" cy="0"/>
-          <a:chOff x="0" y="0"/>
-          <a:chExt cx="0" cy="0"/>
-        </a:xfrm>
-      </p:grpSpPr>
-      <p:sp>
-        <p:nvSpPr>
-          <p:cNvPr id="5" name="Shape 4">
-            <a:extLst>
-              <a:ext uri="{FF2B5EF4-FFF2-40B4-BE49-F238E27FC236}">
-                <a16:creationId xmlns:a16="http://schemas.microsoft.com/office/drawing/2014/main" id="{01E4604A-A2F2-75F3-0A53-CA6CEEF5588D}"/>
-              </a:ext>
-            </a:extLst>
-          </p:cNvPr>
-          <p:cNvSpPr/>
-          <p:nvPr/>
-        </p:nvSpPr>
-        <p:spPr>
-          <a:xfrm>
-            <a:off x="1252800" y="2697493"/>
-            <a:ext cx="6608494" cy="3522054"/>
-          </a:xfrm>
-          <a:prstGeom prst="roundRect">
-            <a:avLst>
-              <a:gd name="adj" fmla="val 4335"/>
-            </a:avLst>
-          </a:prstGeom>
-          <a:solidFill>
-            <a:srgbClr val="D2DDF9"/>
-          </a:solidFill>
-          <a:ln/>
-        </p:spPr>
-        <p:txBody>
-          <a:bodyPr/>
-          <a:lstStyle/>
-          <a:p>
-            <a:endParaRPr lang="de-DE">
-              <a:latin typeface="Arial" panose="020B0604020202020204" pitchFamily="34" charset="0"/>
-              <a:cs typeface="Arial" panose="020B0604020202020204" pitchFamily="34" charset="0"/>
-            </a:endParaRPr>
-          </a:p>
-        </p:txBody>
-      </p:sp>
-      <p:sp>
-        <p:nvSpPr>
-          <p:cNvPr id="2" name="Text 1">
-            <a:extLst>
-              <a:ext uri="{FF2B5EF4-FFF2-40B4-BE49-F238E27FC236}">
-                <a16:creationId xmlns:a16="http://schemas.microsoft.com/office/drawing/2014/main" id="{C62DF92F-1163-B150-A05D-661A035DACD9}"/>
-              </a:ext>
-            </a:extLst>
-          </p:cNvPr>
-          <p:cNvSpPr/>
-          <p:nvPr/>
-        </p:nvSpPr>
-        <p:spPr>
-          <a:xfrm>
-            <a:off x="1483201" y="2600711"/>
-            <a:ext cx="6127200" cy="3715618"/>
-          </a:xfrm>
-          <a:prstGeom prst="rect">
-            <a:avLst/>
-          </a:prstGeom>
-          <a:noFill/>
-          <a:ln/>
-        </p:spPr>
-        <p:txBody>
-          <a:bodyPr wrap="none" lIns="0" tIns="0" rIns="0" bIns="0" rtlCol="0" anchor="t"/>
-          <a:lstStyle/>
-          <a:p>
-            <a:pPr marL="0" indent="0" algn="l">
-              <a:lnSpc>
-                <a:spcPts val="2850"/>
-              </a:lnSpc>
-              <a:buNone/>
-            </a:pPr>
-            <a:endParaRPr lang="en-US" sz="1750" dirty="0">
-              <a:latin typeface="Arial" panose="020B0604020202020204" pitchFamily="34" charset="0"/>
-              <a:ea typeface="Heebo" pitchFamily="34" charset="-122"/>
-              <a:cs typeface="Arial" panose="020B0604020202020204" pitchFamily="34" charset="0"/>
-            </a:endParaRPr>
-          </a:p>
-          <a:p>
-            <a:pPr marL="0" indent="0" algn="l">
-              <a:lnSpc>
-                <a:spcPts val="2850"/>
-              </a:lnSpc>
-              <a:buNone/>
-            </a:pPr>
-            <a:r>
-              <a:rPr lang="en-US" sz="2400" b="1" dirty="0">
-                <a:latin typeface="Arial" panose="020B0604020202020204" pitchFamily="34" charset="0"/>
-                <a:ea typeface="Heebo" pitchFamily="34" charset="-122"/>
-                <a:cs typeface="Arial" panose="020B0604020202020204" pitchFamily="34" charset="0"/>
-              </a:rPr>
-              <a:t>Strengths:</a:t>
-            </a:r>
-          </a:p>
-          <a:p>
-            <a:pPr marL="285750" indent="-285750" algn="l">
-              <a:lnSpc>
-                <a:spcPts val="2850"/>
-              </a:lnSpc>
-              <a:buFont typeface="Arial" panose="020B0604020202020204" pitchFamily="34" charset="0"/>
-              <a:buChar char="•"/>
-            </a:pPr>
-            <a:r>
-              <a:rPr lang="en-US" dirty="0">
-                <a:latin typeface="Arial" panose="020B0604020202020204" pitchFamily="34" charset="0"/>
-                <a:ea typeface="Heebo" pitchFamily="34" charset="-122"/>
-                <a:cs typeface="Arial" panose="020B0604020202020204" pitchFamily="34" charset="0"/>
-              </a:rPr>
-              <a:t>31/32 runs (96%) achieved near-optimal performance</a:t>
-            </a:r>
-          </a:p>
-          <a:p>
-            <a:pPr marL="285750" indent="-285750" algn="l">
-              <a:lnSpc>
-                <a:spcPts val="2850"/>
-              </a:lnSpc>
-              <a:buFont typeface="Arial" panose="020B0604020202020204" pitchFamily="34" charset="0"/>
-              <a:buChar char="•"/>
-            </a:pPr>
-            <a:r>
-              <a:rPr lang="en-US" dirty="0">
-                <a:latin typeface="Arial" panose="020B0604020202020204" pitchFamily="34" charset="0"/>
-                <a:ea typeface="Heebo" pitchFamily="34" charset="-122"/>
-                <a:cs typeface="Arial" panose="020B0604020202020204" pitchFamily="34" charset="0"/>
-              </a:rPr>
-              <a:t>Stable and consistent learning behavior</a:t>
-            </a:r>
-          </a:p>
-          <a:p>
-            <a:pPr marL="285750" indent="-285750" algn="l">
-              <a:lnSpc>
-                <a:spcPts val="2850"/>
-              </a:lnSpc>
-              <a:buFont typeface="Arial" panose="020B0604020202020204" pitchFamily="34" charset="0"/>
-              <a:buChar char="•"/>
-            </a:pPr>
-            <a:r>
-              <a:rPr lang="en-US" dirty="0">
-                <a:latin typeface="Arial" panose="020B0604020202020204" pitchFamily="34" charset="0"/>
-                <a:ea typeface="Heebo" pitchFamily="34" charset="-122"/>
-                <a:cs typeface="Arial" panose="020B0604020202020204" pitchFamily="34" charset="0"/>
-              </a:rPr>
-              <a:t>Model is robust to random initialization</a:t>
-            </a:r>
-          </a:p>
-          <a:p>
-            <a:pPr marL="0" indent="0" algn="l">
-              <a:lnSpc>
-                <a:spcPts val="2850"/>
-              </a:lnSpc>
-              <a:buNone/>
-            </a:pPr>
-            <a:endParaRPr lang="en-US" sz="1750" dirty="0">
-              <a:latin typeface="Arial" panose="020B0604020202020204" pitchFamily="34" charset="0"/>
-              <a:ea typeface="Heebo" pitchFamily="34" charset="-122"/>
-              <a:cs typeface="Arial" panose="020B0604020202020204" pitchFamily="34" charset="0"/>
-            </a:endParaRPr>
-          </a:p>
-          <a:p>
-            <a:pPr marL="0" indent="0" algn="l">
-              <a:lnSpc>
-                <a:spcPts val="2850"/>
-              </a:lnSpc>
-              <a:buNone/>
-            </a:pPr>
-            <a:r>
-              <a:rPr lang="en-US" sz="2400" b="1" dirty="0">
-                <a:latin typeface="Arial" panose="020B0604020202020204" pitchFamily="34" charset="0"/>
-                <a:ea typeface="Heebo" pitchFamily="34" charset="-122"/>
-                <a:cs typeface="Arial" panose="020B0604020202020204" pitchFamily="34" charset="0"/>
-              </a:rPr>
-              <a:t>Weaknesses:</a:t>
-            </a:r>
-          </a:p>
-          <a:p>
-            <a:pPr marL="285750" indent="-285750" algn="l">
-              <a:lnSpc>
-                <a:spcPts val="2850"/>
-              </a:lnSpc>
-              <a:buFont typeface="Arial" panose="020B0604020202020204" pitchFamily="34" charset="0"/>
-              <a:buChar char="•"/>
-            </a:pPr>
-            <a:r>
-              <a:rPr lang="en-US" dirty="0">
-                <a:latin typeface="Arial" panose="020B0604020202020204" pitchFamily="34" charset="0"/>
-                <a:ea typeface="Heebo" pitchFamily="34" charset="-122"/>
-                <a:cs typeface="Arial" panose="020B0604020202020204" pitchFamily="34" charset="0"/>
-              </a:rPr>
-              <a:t>4% chance of suboptimal convergence (1 outliers)</a:t>
-            </a:r>
-          </a:p>
-          <a:p>
-            <a:pPr marL="285750" indent="-285750" algn="l">
-              <a:lnSpc>
-                <a:spcPts val="2850"/>
-              </a:lnSpc>
-              <a:buFont typeface="Arial" panose="020B0604020202020204" pitchFamily="34" charset="0"/>
-              <a:buChar char="•"/>
-            </a:pPr>
-            <a:r>
-              <a:rPr lang="en-US" dirty="0">
-                <a:latin typeface="Arial" panose="020B0604020202020204" pitchFamily="34" charset="0"/>
-                <a:ea typeface="Heebo" pitchFamily="34" charset="-122"/>
-                <a:cs typeface="Arial" panose="020B0604020202020204" pitchFamily="34" charset="0"/>
-              </a:rPr>
-              <a:t>Optimality of the learned policy cannot be guaranteed</a:t>
-            </a:r>
-          </a:p>
-        </p:txBody>
-      </p:sp>
-      <p:sp>
-        <p:nvSpPr>
-          <p:cNvPr id="3" name="TextBox 2">
-            <a:extLst>
-              <a:ext uri="{FF2B5EF4-FFF2-40B4-BE49-F238E27FC236}">
-                <a16:creationId xmlns:a16="http://schemas.microsoft.com/office/drawing/2014/main" id="{F520DBB0-400F-6963-5E18-A67AA7D3E61D}"/>
-              </a:ext>
-            </a:extLst>
-          </p:cNvPr>
-          <p:cNvSpPr txBox="1"/>
-          <p:nvPr/>
-        </p:nvSpPr>
-        <p:spPr>
-          <a:xfrm>
-            <a:off x="1252800" y="634032"/>
-            <a:ext cx="8510400" cy="461665"/>
-          </a:xfrm>
-          <a:prstGeom prst="rect">
-            <a:avLst/>
-          </a:prstGeom>
-          <a:noFill/>
-        </p:spPr>
-        <p:txBody>
-          <a:bodyPr wrap="square" rtlCol="0">
-            <a:spAutoFit/>
-          </a:bodyPr>
-          <a:lstStyle/>
-          <a:p>
-            <a:r>
-              <a:rPr lang="en-US" sz="2400" b="1" i="0" dirty="0">
-                <a:effectLst/>
-                <a:latin typeface="Arial" panose="020B0604020202020204" pitchFamily="34" charset="0"/>
-                <a:cs typeface="Arial" panose="020B0604020202020204" pitchFamily="34" charset="0"/>
-              </a:rPr>
-              <a:t>Analysis of RL Battery Optimization Box Plot (32 Runs)</a:t>
-            </a:r>
-            <a:endParaRPr lang="de-DE" sz="2400" dirty="0">
-              <a:latin typeface="Arial" panose="020B0604020202020204" pitchFamily="34" charset="0"/>
-              <a:cs typeface="Arial" panose="020B0604020202020204" pitchFamily="34" charset="0"/>
-            </a:endParaRPr>
-          </a:p>
-        </p:txBody>
-      </p:sp>
-      <p:sp>
-        <p:nvSpPr>
-          <p:cNvPr id="4" name="TextBox 3">
-            <a:extLst>
-              <a:ext uri="{FF2B5EF4-FFF2-40B4-BE49-F238E27FC236}">
-                <a16:creationId xmlns:a16="http://schemas.microsoft.com/office/drawing/2014/main" id="{DC33ECBD-FB5C-26D7-0EBE-F0CD0278B8AA}"/>
-              </a:ext>
-            </a:extLst>
-          </p:cNvPr>
-          <p:cNvSpPr txBox="1"/>
-          <p:nvPr/>
-        </p:nvSpPr>
-        <p:spPr>
-          <a:xfrm>
-            <a:off x="1252800" y="1304257"/>
-            <a:ext cx="10021132" cy="923330"/>
-          </a:xfrm>
-          <a:prstGeom prst="rect">
-            <a:avLst/>
-          </a:prstGeom>
-          <a:noFill/>
-        </p:spPr>
-        <p:txBody>
-          <a:bodyPr wrap="square" rtlCol="0">
-            <a:spAutoFit/>
-          </a:bodyPr>
-          <a:lstStyle/>
-          <a:p>
-            <a:r>
-              <a:rPr lang="en-US" dirty="0"/>
-              <a:t>The linear learning rate schedule performs best because it achieves the lowest median cost and maintains a tight distribution across runs, indicating stable and reliable convergence. The linear decay allows large updates during early exploration and smaller updates for fine policy refinement later in training.</a:t>
-            </a:r>
-            <a:endParaRPr lang="de-DE" dirty="0"/>
-          </a:p>
-        </p:txBody>
-      </p:sp>
-      <p:sp>
-        <p:nvSpPr>
-          <p:cNvPr id="7" name="Slide Number Placeholder 6">
-            <a:extLst>
-              <a:ext uri="{FF2B5EF4-FFF2-40B4-BE49-F238E27FC236}">
-                <a16:creationId xmlns:a16="http://schemas.microsoft.com/office/drawing/2014/main" id="{CB67F05D-BF83-0E4E-252C-F73DCCA6881F}"/>
-              </a:ext>
-            </a:extLst>
-          </p:cNvPr>
-          <p:cNvSpPr>
-            <a:spLocks noGrp="1"/>
-          </p:cNvSpPr>
-          <p:nvPr>
-            <p:ph type="sldNum" sz="quarter" idx="10"/>
-          </p:nvPr>
-        </p:nvSpPr>
-        <p:spPr/>
-        <p:txBody>
-          <a:bodyPr/>
-          <a:lstStyle/>
-          <a:p>
-            <a:fld id="{A02D9A9C-251E-4686-914B-47E3F39F30D8}" type="slidenum">
-              <a:rPr lang="de-DE" smtClean="0"/>
-              <a:t>9</a:t>
-            </a:fld>
-            <a:endParaRPr lang="de-DE"/>
-          </a:p>
-        </p:txBody>
-      </p:sp>
-    </p:spTree>
-    <p:extLst>
-      <p:ext uri="{BB962C8B-B14F-4D97-AF65-F5344CB8AC3E}">
-        <p14:creationId xmlns:p14="http://schemas.microsoft.com/office/powerpoint/2010/main" val="3161864785"/>
       </p:ext>
     </p:extLst>
   </p:cSld>

</xml_diff>